<commit_message>
Slides: cover without footer at 108 px, separate provider lock from module version (sd-13-018)
Co-Authored-By: Claude Sonnet 5.5 <noreply@anthropic.com>
Claude-Session: https://claude.ai/code/session_01EhxTYrCJpuk4mcqCLwPdds
</commit_message>
<xml_diff>
--- a/system-design-101/vi/lessons/sd-06-010/slides/sd-06-010.pptx
+++ b/system-design-101/vi/lessons/sd-06-010/slides/sd-06-010.pptx
@@ -1794,7 +1794,7 @@
         <p:spPr>
           <a:xfrm>
             <a:off x="914400" y="1524000"/>
-            <a:ext cx="16459200" cy="2476500"/>
+            <a:ext cx="16459200" cy="2571750"/>
           </a:xfrm>
           <a:prstGeom prst="rect">
             <a:avLst/>
@@ -1810,7 +1810,7 @@
               <a:buNone/>
             </a:pPr>
             <a:r>
-              <a:rPr lang="en-US" sz="7500" dirty="0" spc="-1" kern="0">
+              <a:rPr lang="en-US" sz="8100" dirty="0" spc="0" kern="0">
                 <a:solidFill>
                   <a:srgbClr val="F3EEE3"/>
                 </a:solidFill>
@@ -1818,10 +1818,10 @@
                 <a:ea typeface="Bricolage Grotesque ExtraBold" pitchFamily="34" charset="-122"/>
                 <a:cs typeface="Bricolage Grotesque ExtraBold" pitchFamily="34" charset="-120"/>
               </a:rPr>
-              <a:t>Các</a:t>
-            </a:r>
-            <a:r>
-              <a:rPr lang="en-US" sz="7500" dirty="0" spc="3" kern="0">
+              <a:t>Các chính sách</a:t>
+            </a:r>
+            <a:r>
+              <a:rPr lang="en-US" sz="8100" dirty="0" spc="11" kern="0">
                 <a:solidFill>
                   <a:srgbClr val="F3EEE3"/>
                 </a:solidFill>
@@ -1829,10 +1829,10 @@
                 <a:ea typeface="Bricolage Grotesque ExtraBold" pitchFamily="34" charset="-122"/>
                 <a:cs typeface="Bricolage Grotesque ExtraBold" pitchFamily="34" charset="-120"/>
               </a:rPr>
-              <a:t> chính</a:t>
-            </a:r>
-            <a:r>
-              <a:rPr lang="en-US" sz="7500" dirty="0" spc="0" kern="0">
+              <a:t> đẩy</a:t>
+            </a:r>
+            <a:r>
+              <a:rPr lang="en-US" sz="8100" dirty="0" spc="-9" kern="0">
                 <a:solidFill>
                   <a:srgbClr val="F3EEE3"/>
                 </a:solidFill>
@@ -1840,10 +1840,10 @@
                 <a:ea typeface="Bricolage Grotesque ExtraBold" pitchFamily="34" charset="-122"/>
                 <a:cs typeface="Bricolage Grotesque ExtraBold" pitchFamily="34" charset="-120"/>
               </a:rPr>
-              <a:t> sách</a:t>
-            </a:r>
-            <a:r>
-              <a:rPr lang="en-US" sz="7500" dirty="0" spc="11" kern="0">
+              <a:t> khóa</a:t>
+            </a:r>
+            <a:r>
+              <a:rPr lang="en-US" sz="8100" dirty="0" spc="-48" kern="0">
                 <a:solidFill>
                   <a:srgbClr val="F3EEE3"/>
                 </a:solidFill>
@@ -1851,10 +1851,10 @@
                 <a:ea typeface="Bricolage Grotesque ExtraBold" pitchFamily="34" charset="-122"/>
                 <a:cs typeface="Bricolage Grotesque ExtraBold" pitchFamily="34" charset="-120"/>
               </a:rPr>
-              <a:t> đẩy</a:t>
-            </a:r>
-            <a:r>
-              <a:rPr lang="en-US" sz="7500" dirty="0" spc="-8" kern="0">
+              <a:t> ra</a:t>
+            </a:r>
+            <a:r>
+              <a:rPr lang="en-US" sz="8100" dirty="0" spc="-2" kern="0">
                 <a:solidFill>
                   <a:srgbClr val="F3EEE3"/>
                 </a:solidFill>
@@ -1862,10 +1862,10 @@
                 <a:ea typeface="Bricolage Grotesque ExtraBold" pitchFamily="34" charset="-122"/>
                 <a:cs typeface="Bricolage Grotesque ExtraBold" pitchFamily="34" charset="-120"/>
               </a:rPr>
-              <a:t> khóa</a:t>
-            </a:r>
-            <a:r>
-              <a:rPr lang="en-US" sz="7500" dirty="0" spc="-45" kern="0">
+              <a:t> khỏi</a:t>
+            </a:r>
+            <a:r>
+              <a:rPr lang="en-US" sz="8100" dirty="0" spc="2" kern="0">
                 <a:solidFill>
                   <a:srgbClr val="F3EEE3"/>
                 </a:solidFill>
@@ -1873,10 +1873,10 @@
                 <a:ea typeface="Bricolage Grotesque ExtraBold" pitchFamily="34" charset="-122"/>
                 <a:cs typeface="Bricolage Grotesque ExtraBold" pitchFamily="34" charset="-120"/>
               </a:rPr>
-              <a:t> ra</a:t>
-            </a:r>
-            <a:r>
-              <a:rPr lang="en-US" sz="7500" dirty="0" spc="1" kern="0">
+              <a:t> bộ</a:t>
+            </a:r>
+            <a:r>
+              <a:rPr lang="en-US" sz="8100" dirty="0" spc="-1" kern="0">
                 <a:solidFill>
                   <a:srgbClr val="F3EEE3"/>
                 </a:solidFill>
@@ -1884,10 +1884,10 @@
                 <a:ea typeface="Bricolage Grotesque ExtraBold" pitchFamily="34" charset="-122"/>
                 <a:cs typeface="Bricolage Grotesque ExtraBold" pitchFamily="34" charset="-120"/>
               </a:rPr>
-              <a:t> khỏi</a:t>
-            </a:r>
-            <a:r>
-              <a:rPr lang="en-US" sz="7500" dirty="0" spc="-2" kern="0">
+              <a:t> nhớ</a:t>
+            </a:r>
+            <a:r>
+              <a:rPr lang="en-US" sz="8100" dirty="0" spc="20" kern="0">
                 <a:solidFill>
                   <a:srgbClr val="F3EEE3"/>
                 </a:solidFill>
@@ -1895,31 +1895,9 @@
                 <a:ea typeface="Bricolage Grotesque ExtraBold" pitchFamily="34" charset="-122"/>
                 <a:cs typeface="Bricolage Grotesque ExtraBold" pitchFamily="34" charset="-120"/>
               </a:rPr>
-              <a:t> bộ</a:t>
-            </a:r>
-            <a:r>
-              <a:rPr lang="en-US" sz="7500" dirty="0" spc="2" kern="0">
-                <a:solidFill>
-                  <a:srgbClr val="F3EEE3"/>
-                </a:solidFill>
-                <a:latin typeface="Bricolage Grotesque ExtraBold" pitchFamily="34" charset="0"/>
-                <a:ea typeface="Bricolage Grotesque ExtraBold" pitchFamily="34" charset="-122"/>
-                <a:cs typeface="Bricolage Grotesque ExtraBold" pitchFamily="34" charset="-120"/>
-              </a:rPr>
-              <a:t> nhớ</a:t>
-            </a:r>
-            <a:r>
-              <a:rPr lang="en-US" sz="7500" dirty="0" spc="18" kern="0">
-                <a:solidFill>
-                  <a:srgbClr val="F3EEE3"/>
-                </a:solidFill>
-                <a:latin typeface="Bricolage Grotesque ExtraBold" pitchFamily="34" charset="0"/>
-                <a:ea typeface="Bricolage Grotesque ExtraBold" pitchFamily="34" charset="-122"/>
-                <a:cs typeface="Bricolage Grotesque ExtraBold" pitchFamily="34" charset="-120"/>
-              </a:rPr>
               <a:t> đệm</a:t>
             </a:r>
-            <a:endParaRPr lang="en-US" sz="7500" dirty="0"/>
+            <a:endParaRPr lang="en-US" sz="8100" dirty="0"/>
           </a:p>
         </p:txBody>
       </p:sp>

</xml_diff>

<commit_message>
Slides: show the simulation results (sd-06-010), describe memcached without limiting it to set and get (sd-06-011)
Co-Authored-By: Claude Sonnet 5.5 <noreply@anthropic.com>
Claude-Session: https://claude.ai/code/session_01EhxTYrCJpuk4mcqCLwPdds
</commit_message>
<xml_diff>
--- a/system-design-101/vi/lessons/sd-06-010/slides/sd-06-010.pptx
+++ b/system-design-101/vi/lessons/sd-06-010/slides/sd-06-010.pptx
@@ -11177,7 +11177,7 @@
               <a:buNone/>
             </a:pPr>
             <a:r>
-              <a:rPr lang="en-US" sz="6300" dirty="0" spc="0" kern="0">
+              <a:rPr lang="en-US" sz="6300" dirty="0" spc="-46" kern="0">
                 <a:solidFill>
                   <a:srgbClr val="F3EEE3"/>
                 </a:solidFill>
@@ -11185,10 +11185,10 @@
                 <a:ea typeface="Bricolage Grotesque ExtraBold" pitchFamily="34" charset="-122"/>
                 <a:cs typeface="Bricolage Grotesque ExtraBold" pitchFamily="34" charset="-120"/>
               </a:rPr>
-              <a:t>Mô</a:t>
-            </a:r>
-            <a:r>
-              <a:rPr lang="en-US" sz="6300" dirty="0" spc="3" kern="0">
+              <a:t>Tỷ</a:t>
+            </a:r>
+            <a:r>
+              <a:rPr lang="en-US" sz="6300" dirty="0" spc="0" kern="0">
                 <a:solidFill>
                   <a:srgbClr val="F3EEE3"/>
                 </a:solidFill>
@@ -11196,10 +11196,10 @@
                 <a:ea typeface="Bricolage Grotesque ExtraBold" pitchFamily="34" charset="-122"/>
                 <a:cs typeface="Bricolage Grotesque ExtraBold" pitchFamily="34" charset="-120"/>
               </a:rPr>
-              <a:t> phỏng</a:t>
-            </a:r>
-            <a:r>
-              <a:rPr lang="en-US" sz="6300" dirty="0" spc="1" kern="0">
+              <a:t> lệ</a:t>
+            </a:r>
+            <a:r>
+              <a:rPr lang="en-US" sz="6300" dirty="0" spc="5" kern="0">
                 <a:solidFill>
                   <a:srgbClr val="F3EEE3"/>
                 </a:solidFill>
@@ -11207,10 +11207,10 @@
                 <a:ea typeface="Bricolage Grotesque ExtraBold" pitchFamily="34" charset="-122"/>
                 <a:cs typeface="Bricolage Grotesque ExtraBold" pitchFamily="34" charset="-120"/>
               </a:rPr>
-              <a:t> chạy</a:t>
-            </a:r>
-            <a:r>
-              <a:rPr lang="en-US" sz="6300" dirty="0" spc="2" kern="0">
+              <a:t> trúng</a:t>
+            </a:r>
+            <a:r>
+              <a:rPr lang="en-US" sz="6300" dirty="0" spc="-93" kern="0">
                 <a:solidFill>
                   <a:srgbClr val="F3EEE3"/>
                 </a:solidFill>
@@ -11218,10 +11218,10 @@
                 <a:ea typeface="Bricolage Grotesque ExtraBold" pitchFamily="34" charset="-122"/>
                 <a:cs typeface="Bricolage Grotesque ExtraBold" pitchFamily="34" charset="-120"/>
               </a:rPr>
-              <a:t> thế</a:t>
-            </a:r>
-            <a:r>
-              <a:rPr lang="en-US" sz="6300" dirty="0" spc="1" kern="0">
+              <a:t> (%)</a:t>
+            </a:r>
+            <a:r>
+              <a:rPr lang="en-US" sz="6300" dirty="0" spc="2" kern="0">
                 <a:solidFill>
                   <a:srgbClr val="F3EEE3"/>
                 </a:solidFill>
@@ -11229,7 +11229,29 @@
                 <a:ea typeface="Bricolage Grotesque ExtraBold" pitchFamily="34" charset="-122"/>
                 <a:cs typeface="Bricolage Grotesque ExtraBold" pitchFamily="34" charset="-120"/>
               </a:rPr>
-              <a:t> nào</a:t>
+              <a:t> theo kiểu</a:t>
+            </a:r>
+            <a:r>
+              <a:rPr lang="en-US" sz="6300" dirty="0" spc="5" kern="0">
+                <a:solidFill>
+                  <a:srgbClr val="F3EEE3"/>
+                </a:solidFill>
+                <a:latin typeface="Bricolage Grotesque ExtraBold" pitchFamily="34" charset="0"/>
+                <a:ea typeface="Bricolage Grotesque ExtraBold" pitchFamily="34" charset="-122"/>
+                <a:cs typeface="Bricolage Grotesque ExtraBold" pitchFamily="34" charset="-120"/>
+              </a:rPr>
+              <a:t> truy</a:t>
+            </a:r>
+            <a:r>
+              <a:rPr lang="en-US" sz="6300" dirty="0" spc="0" kern="0">
+                <a:solidFill>
+                  <a:srgbClr val="F3EEE3"/>
+                </a:solidFill>
+                <a:latin typeface="Bricolage Grotesque ExtraBold" pitchFamily="34" charset="0"/>
+                <a:ea typeface="Bricolage Grotesque ExtraBold" pitchFamily="34" charset="-122"/>
+                <a:cs typeface="Bricolage Grotesque ExtraBold" pitchFamily="34" charset="-120"/>
+              </a:rPr>
+              <a:t> cập</a:t>
             </a:r>
             <a:endParaRPr lang="en-US" sz="6300" dirty="0"/>
           </a:p>
@@ -11287,7 +11309,7 @@
               <a:buNone/>
             </a:pPr>
             <a:r>
-              <a:rPr lang="en-US" sz="2850" dirty="0" spc="-6" kern="0">
+              <a:rPr lang="en-US" sz="2850" dirty="0" spc="-34" kern="0">
                 <a:solidFill>
                   <a:srgbClr val="3DD6A0"/>
                 </a:solidFill>
@@ -11295,10 +11317,10 @@
                 <a:ea typeface="Be Vietnam Pro ExtraBold" pitchFamily="34" charset="-122"/>
                 <a:cs typeface="Be Vietnam Pro ExtraBold" pitchFamily="34" charset="-120"/>
               </a:rPr>
-              <a:t>Mỗi</a:t>
-            </a:r>
-            <a:r>
-              <a:rPr lang="en-US" sz="2850" dirty="0" spc="0" kern="0">
+              <a:t>Truy</a:t>
+            </a:r>
+            <a:r>
+              <a:rPr lang="en-US" sz="2850" dirty="0" spc="-1" kern="0">
                 <a:solidFill>
                   <a:srgbClr val="3DD6A0"/>
                 </a:solidFill>
@@ -11306,10 +11328,10 @@
                 <a:ea typeface="Be Vietnam Pro ExtraBold" pitchFamily="34" charset="-122"/>
                 <a:cs typeface="Be Vietnam Pro ExtraBold" pitchFamily="34" charset="-120"/>
               </a:rPr>
-              <a:t> chính</a:t>
-            </a:r>
-            <a:r>
-              <a:rPr lang="en-US" sz="2850" dirty="0" spc="4" kern="0">
+              <a:t> cập</a:t>
+            </a:r>
+            <a:r>
+              <a:rPr lang="en-US" sz="2850" dirty="0" spc="-8" kern="0">
                 <a:solidFill>
                   <a:srgbClr val="3DD6A0"/>
                 </a:solidFill>
@@ -11317,10 +11339,10 @@
                 <a:ea typeface="Be Vietnam Pro ExtraBold" pitchFamily="34" charset="-122"/>
                 <a:cs typeface="Be Vietnam Pro ExtraBold" pitchFamily="34" charset="-120"/>
               </a:rPr>
-              <a:t> sách</a:t>
-            </a:r>
-            <a:r>
-              <a:rPr lang="en-US" sz="2850" dirty="0" spc="-4" kern="0">
+              <a:t> lệch</a:t>
+            </a:r>
+            <a:r>
+              <a:rPr lang="en-US" sz="2850" dirty="0" spc="-5" kern="0">
                 <a:solidFill>
                   <a:srgbClr val="3DD6A0"/>
                 </a:solidFill>
@@ -11328,29 +11350,7 @@
                 <a:ea typeface="Be Vietnam Pro ExtraBold" pitchFamily="34" charset="-122"/>
                 <a:cs typeface="Be Vietnam Pro ExtraBold" pitchFamily="34" charset="-120"/>
               </a:rPr>
-              <a:t> là</a:t>
-            </a:r>
-            <a:r>
-              <a:rPr lang="en-US" sz="2850" dirty="0" spc="-13" kern="0">
-                <a:solidFill>
-                  <a:srgbClr val="3DD6A0"/>
-                </a:solidFill>
-                <a:latin typeface="Be Vietnam Pro ExtraBold" pitchFamily="34" charset="0"/>
-                <a:ea typeface="Be Vietnam Pro ExtraBold" pitchFamily="34" charset="-122"/>
-                <a:cs typeface="Be Vietnam Pro ExtraBold" pitchFamily="34" charset="-120"/>
-              </a:rPr>
-              <a:t> một</a:t>
-            </a:r>
-            <a:r>
-              <a:rPr lang="en-US" sz="2850" dirty="0" spc="-4" kern="0">
-                <a:solidFill>
-                  <a:srgbClr val="3DD6A0"/>
-                </a:solidFill>
-                <a:latin typeface="Be Vietnam Pro ExtraBold" pitchFamily="34" charset="0"/>
-                <a:ea typeface="Be Vietnam Pro ExtraBold" pitchFamily="34" charset="-122"/>
-                <a:cs typeface="Be Vietnam Pro ExtraBold" pitchFamily="34" charset="-120"/>
-              </a:rPr>
-              <a:t> hàm</a:t>
+              <a:t> (Zipf)</a:t>
             </a:r>
             <a:endParaRPr lang="en-US" sz="2850" dirty="0"/>
           </a:p>
@@ -11381,6 +11381,105 @@
               <a:buNone/>
             </a:pPr>
             <a:r>
+              <a:rPr lang="en-US" sz="2400" dirty="0" spc="-1" kern="0">
+                <a:solidFill>
+                  <a:srgbClr val="F3EEE3"/>
+                </a:solidFill>
+                <a:latin typeface="Be Vietnam Pro" pitchFamily="34" charset="0"/>
+                <a:ea typeface="Be Vietnam Pro" pitchFamily="34" charset="-122"/>
+                <a:cs typeface="Be Vietnam Pro" pitchFamily="34" charset="-120"/>
+              </a:rPr>
+              <a:t>LFU,</a:t>
+            </a:r>
+            <a:r>
+              <a:rPr lang="en-US" sz="2400" dirty="0" spc="-13" kern="0">
+                <a:solidFill>
+                  <a:srgbClr val="F3EEE3"/>
+                </a:solidFill>
+                <a:latin typeface="Be Vietnam Pro" pitchFamily="34" charset="0"/>
+                <a:ea typeface="Be Vietnam Pro" pitchFamily="34" charset="-122"/>
+                <a:cs typeface="Be Vietnam Pro" pitchFamily="34" charset="-120"/>
+              </a:rPr>
+              <a:t> SLRU</a:t>
+            </a:r>
+            <a:r>
+              <a:rPr lang="en-US" sz="2400" dirty="0" spc="-2" kern="0">
+                <a:solidFill>
+                  <a:srgbClr val="F3EEE3"/>
+                </a:solidFill>
+                <a:latin typeface="Be Vietnam Pro" pitchFamily="34" charset="0"/>
+                <a:ea typeface="Be Vietnam Pro" pitchFamily="34" charset="-122"/>
+                <a:cs typeface="Be Vietnam Pro" pitchFamily="34" charset="-120"/>
+              </a:rPr>
+              <a:t> 65,5</a:t>
+            </a:r>
+            <a:r>
+              <a:rPr lang="en-US" sz="2400" dirty="0" spc="1" kern="0">
+                <a:solidFill>
+                  <a:srgbClr val="F3EEE3"/>
+                </a:solidFill>
+                <a:latin typeface="Be Vietnam Pro" pitchFamily="34" charset="0"/>
+                <a:ea typeface="Be Vietnam Pro" pitchFamily="34" charset="-122"/>
+                <a:cs typeface="Be Vietnam Pro" pitchFamily="34" charset="-120"/>
+              </a:rPr>
+              <a:t> ·</a:t>
+            </a:r>
+            <a:r>
+              <a:rPr lang="en-US" sz="2400" dirty="0" spc="-17" kern="0">
+                <a:solidFill>
+                  <a:srgbClr val="F3EEE3"/>
+                </a:solidFill>
+                <a:latin typeface="Be Vietnam Pro" pitchFamily="34" charset="0"/>
+                <a:ea typeface="Be Vietnam Pro" pitchFamily="34" charset="-122"/>
+                <a:cs typeface="Be Vietnam Pro" pitchFamily="34" charset="-120"/>
+              </a:rPr>
+              <a:t> LRU</a:t>
+            </a:r>
+            <a:r>
+              <a:rPr lang="en-US" sz="2400" dirty="0" spc="-1" kern="0">
+                <a:solidFill>
+                  <a:srgbClr val="F3EEE3"/>
+                </a:solidFill>
+                <a:latin typeface="Be Vietnam Pro" pitchFamily="34" charset="0"/>
+                <a:ea typeface="Be Vietnam Pro" pitchFamily="34" charset="-122"/>
+                <a:cs typeface="Be Vietnam Pro" pitchFamily="34" charset="-120"/>
+              </a:rPr>
+              <a:t> 57,9</a:t>
+            </a:r>
+            <a:r>
+              <a:rPr lang="en-US" sz="2400" dirty="0" spc="1" kern="0">
+                <a:solidFill>
+                  <a:srgbClr val="F3EEE3"/>
+                </a:solidFill>
+                <a:latin typeface="Be Vietnam Pro" pitchFamily="34" charset="0"/>
+                <a:ea typeface="Be Vietnam Pro" pitchFamily="34" charset="-122"/>
+                <a:cs typeface="Be Vietnam Pro" pitchFamily="34" charset="-120"/>
+              </a:rPr>
+              <a:t> ·</a:t>
+            </a:r>
+            <a:r>
+              <a:rPr lang="en-US" sz="2400" dirty="0" spc="-11" kern="0">
+                <a:solidFill>
+                  <a:srgbClr val="F3EEE3"/>
+                </a:solidFill>
+                <a:latin typeface="Be Vietnam Pro" pitchFamily="34" charset="0"/>
+                <a:ea typeface="Be Vietnam Pro" pitchFamily="34" charset="-122"/>
+                <a:cs typeface="Be Vietnam Pro" pitchFamily="34" charset="-120"/>
+              </a:rPr>
+              <a:t> FIFO,</a:t>
+            </a:r>
+            <a:r>
+              <a:rPr lang="en-US" sz="2400" dirty="0" spc="-8" kern="0">
+                <a:solidFill>
+                  <a:srgbClr val="F3EEE3"/>
+                </a:solidFill>
+                <a:latin typeface="Be Vietnam Pro" pitchFamily="34" charset="0"/>
+                <a:ea typeface="Be Vietnam Pro" pitchFamily="34" charset="-122"/>
+                <a:cs typeface="Be Vietnam Pro" pitchFamily="34" charset="-120"/>
+              </a:rPr>
+              <a:t> ngẫu</a:t>
+            </a:r>
+            <a:r>
               <a:rPr lang="en-US" sz="2400" dirty="0" spc="0" kern="0">
                 <a:solidFill>
                   <a:srgbClr val="F3EEE3"/>
@@ -11389,84 +11488,62 @@
                 <a:ea typeface="Be Vietnam Pro" pitchFamily="34" charset="-122"/>
                 <a:cs typeface="Be Vietnam Pro" pitchFamily="34" charset="-120"/>
               </a:rPr>
-              <a:t>Nhận</a:t>
-            </a:r>
-            <a:r>
-              <a:rPr lang="en-US" sz="2400" dirty="0" spc="-2" kern="0">
-                <a:solidFill>
-                  <a:srgbClr val="F3EEE3"/>
-                </a:solidFill>
-                <a:latin typeface="Be Vietnam Pro" pitchFamily="34" charset="0"/>
-                <a:ea typeface="Be Vietnam Pro" pitchFamily="34" charset="-122"/>
-                <a:cs typeface="Be Vietnam Pro" pitchFamily="34" charset="-120"/>
-              </a:rPr>
-              <a:t> chuỗi khóa</a:t>
-            </a:r>
-            <a:r>
-              <a:rPr lang="en-US" sz="2400" dirty="0" spc="-15" kern="0">
-                <a:solidFill>
-                  <a:srgbClr val="F3EEE3"/>
-                </a:solidFill>
-                <a:latin typeface="Be Vietnam Pro" pitchFamily="34" charset="0"/>
-                <a:ea typeface="Be Vietnam Pro" pitchFamily="34" charset="-122"/>
-                <a:cs typeface="Be Vietnam Pro" pitchFamily="34" charset="-120"/>
-              </a:rPr>
-              <a:t> và</a:t>
-            </a:r>
-            <a:r>
-              <a:rPr lang="en-US" sz="2400" dirty="0" spc="9" kern="0">
-                <a:solidFill>
-                  <a:srgbClr val="F3EEE3"/>
-                </a:solidFill>
-                <a:latin typeface="Be Vietnam Pro" pitchFamily="34" charset="0"/>
-                <a:ea typeface="Be Vietnam Pro" pitchFamily="34" charset="-122"/>
-                <a:cs typeface="Be Vietnam Pro" pitchFamily="34" charset="-120"/>
-              </a:rPr>
-              <a:t> sức</a:t>
-            </a:r>
-            <a:r>
-              <a:rPr lang="en-US" sz="2400" dirty="0" spc="7" kern="0">
-                <a:solidFill>
-                  <a:srgbClr val="F3EEE3"/>
-                </a:solidFill>
-                <a:latin typeface="Be Vietnam Pro" pitchFamily="34" charset="0"/>
-                <a:ea typeface="Be Vietnam Pro" pitchFamily="34" charset="-122"/>
-                <a:cs typeface="Be Vietnam Pro" pitchFamily="34" charset="-120"/>
-              </a:rPr>
-              <a:t> chứa,</a:t>
-            </a:r>
-            <a:r>
-              <a:rPr lang="en-US" sz="2400" dirty="0" spc="14" kern="0">
-                <a:solidFill>
-                  <a:srgbClr val="F3EEE3"/>
-                </a:solidFill>
-                <a:latin typeface="Be Vietnam Pro" pitchFamily="34" charset="0"/>
-                <a:ea typeface="Be Vietnam Pro" pitchFamily="34" charset="-122"/>
-                <a:cs typeface="Be Vietnam Pro" pitchFamily="34" charset="-120"/>
-              </a:rPr>
-              <a:t> đếm</a:t>
-            </a:r>
-            <a:r>
-              <a:rPr lang="en-US" sz="2400" dirty="0" spc="8" kern="0">
-                <a:solidFill>
-                  <a:srgbClr val="F3EEE3"/>
-                </a:solidFill>
-                <a:latin typeface="Be Vietnam Pro" pitchFamily="34" charset="0"/>
-                <a:ea typeface="Be Vietnam Pro" pitchFamily="34" charset="-122"/>
-                <a:cs typeface="Be Vietnam Pro" pitchFamily="34" charset="-120"/>
-              </a:rPr>
-              <a:t> lượt</a:t>
-            </a:r>
-            <a:r>
-              <a:rPr lang="en-US" sz="2400" dirty="0" spc="2" kern="0">
-                <a:solidFill>
-                  <a:srgbClr val="F3EEE3"/>
-                </a:solidFill>
-                <a:latin typeface="Be Vietnam Pro" pitchFamily="34" charset="0"/>
-                <a:ea typeface="Be Vietnam Pro" pitchFamily="34" charset="-122"/>
-                <a:cs typeface="Be Vietnam Pro" pitchFamily="34" charset="-120"/>
-              </a:rPr>
-              <a:t> trúng.</a:t>
+              <a:t> nhiên</a:t>
+            </a:r>
+            <a:r>
+              <a:rPr lang="en-US" sz="2400" dirty="0" spc="-1" kern="0">
+                <a:solidFill>
+                  <a:srgbClr val="F3EEE3"/>
+                </a:solidFill>
+                <a:latin typeface="Be Vietnam Pro" pitchFamily="34" charset="0"/>
+                <a:ea typeface="Be Vietnam Pro" pitchFamily="34" charset="-122"/>
+                <a:cs typeface="Be Vietnam Pro" pitchFamily="34" charset="-120"/>
+              </a:rPr>
+              <a:t> khoảng</a:t>
+            </a:r>
+            <a:r>
+              <a:rPr lang="en-US" sz="2400" dirty="0" spc="0" kern="0">
+                <a:solidFill>
+                  <a:srgbClr val="F3EEE3"/>
+                </a:solidFill>
+                <a:latin typeface="Be Vietnam Pro" pitchFamily="34" charset="0"/>
+                <a:ea typeface="Be Vietnam Pro" pitchFamily="34" charset="-122"/>
+                <a:cs typeface="Be Vietnam Pro" pitchFamily="34" charset="-120"/>
+              </a:rPr>
+              <a:t> 52</a:t>
+            </a:r>
+            <a:r>
+              <a:rPr lang="en-US" sz="2400" dirty="0" spc="1" kern="0">
+                <a:solidFill>
+                  <a:srgbClr val="F3EEE3"/>
+                </a:solidFill>
+                <a:latin typeface="Be Vietnam Pro" pitchFamily="34" charset="0"/>
+                <a:ea typeface="Be Vietnam Pro" pitchFamily="34" charset="-122"/>
+                <a:cs typeface="Be Vietnam Pro" pitchFamily="34" charset="-120"/>
+              </a:rPr>
+              <a:t> ·</a:t>
+            </a:r>
+            <a:r>
+              <a:rPr lang="en-US" sz="2400" dirty="0" spc="-17" kern="0">
+                <a:solidFill>
+                  <a:srgbClr val="F3EEE3"/>
+                </a:solidFill>
+                <a:latin typeface="Be Vietnam Pro" pitchFamily="34" charset="0"/>
+                <a:ea typeface="Be Vietnam Pro" pitchFamily="34" charset="-122"/>
+                <a:cs typeface="Be Vietnam Pro" pitchFamily="34" charset="-120"/>
+              </a:rPr>
+              <a:t> MRU</a:t>
+            </a:r>
+            <a:r>
+              <a:rPr lang="en-US" sz="2400" dirty="0" spc="0" kern="0">
+                <a:solidFill>
+                  <a:srgbClr val="F3EEE3"/>
+                </a:solidFill>
+                <a:latin typeface="Be Vietnam Pro" pitchFamily="34" charset="0"/>
+                <a:ea typeface="Be Vietnam Pro" pitchFamily="34" charset="-122"/>
+                <a:cs typeface="Be Vietnam Pro" pitchFamily="34" charset="-120"/>
+              </a:rPr>
+              <a:t> 12,6</a:t>
             </a:r>
             <a:endParaRPr lang="en-US" sz="2400" dirty="0"/>
           </a:p>
@@ -11524,7 +11601,7 @@
               <a:buNone/>
             </a:pPr>
             <a:r>
-              <a:rPr lang="en-US" sz="2850" dirty="0" spc="0" kern="0">
+              <a:rPr lang="en-US" sz="2850" dirty="0" spc="-16" kern="0">
                 <a:solidFill>
                   <a:srgbClr val="FF6A4D"/>
                 </a:solidFill>
@@ -11532,10 +11609,10 @@
                 <a:ea typeface="Be Vietnam Pro ExtraBold" pitchFamily="34" charset="-122"/>
                 <a:cs typeface="Be Vietnam Pro ExtraBold" pitchFamily="34" charset="-120"/>
               </a:rPr>
-              <a:t>LFU</a:t>
-            </a:r>
-            <a:r>
-              <a:rPr lang="en-US" sz="2850" dirty="0" spc="-10" kern="0">
+              <a:t>Lặp</a:t>
+            </a:r>
+            <a:r>
+              <a:rPr lang="en-US" sz="2850" dirty="0" spc="-23" kern="0">
                 <a:solidFill>
                   <a:srgbClr val="FF6A4D"/>
                 </a:solidFill>
@@ -11543,10 +11620,10 @@
                 <a:ea typeface="Be Vietnam Pro ExtraBold" pitchFamily="34" charset="-122"/>
                 <a:cs typeface="Be Vietnam Pro ExtraBold" pitchFamily="34" charset="-120"/>
               </a:rPr>
-              <a:t> phá</a:t>
-            </a:r>
-            <a:r>
-              <a:rPr lang="en-US" sz="2850" dirty="0" spc="-7" kern="0">
+              <a:t> vòng</a:t>
+            </a:r>
+            <a:r>
+              <a:rPr lang="en-US" sz="2850" dirty="0" spc="0" kern="0">
                 <a:solidFill>
                   <a:srgbClr val="FF6A4D"/>
                 </a:solidFill>
@@ -11554,7 +11631,18 @@
                 <a:ea typeface="Be Vietnam Pro ExtraBold" pitchFamily="34" charset="-122"/>
                 <a:cs typeface="Be Vietnam Pro ExtraBold" pitchFamily="34" charset="-120"/>
               </a:rPr>
-              <a:t> hòa</a:t>
+              <a:t> 120</a:t>
+            </a:r>
+            <a:r>
+              <a:rPr lang="en-US" sz="2850" dirty="0" spc="-6" kern="0">
+                <a:solidFill>
+                  <a:srgbClr val="FF6A4D"/>
+                </a:solidFill>
+                <a:latin typeface="Be Vietnam Pro ExtraBold" pitchFamily="34" charset="0"/>
+                <a:ea typeface="Be Vietnam Pro ExtraBold" pitchFamily="34" charset="-122"/>
+                <a:cs typeface="Be Vietnam Pro ExtraBold" pitchFamily="34" charset="-120"/>
+              </a:rPr>
+              <a:t> khóa</a:t>
             </a:r>
             <a:endParaRPr lang="en-US" sz="2850" dirty="0"/>
           </a:p>
@@ -11585,15 +11673,15 @@
               <a:buNone/>
             </a:pPr>
             <a:r>
-              <a:rPr lang="en-US" sz="2400" dirty="0" spc="4" kern="0">
-                <a:solidFill>
-                  <a:srgbClr val="F3EEE3"/>
-                </a:solidFill>
-                <a:latin typeface="Be Vietnam Pro" pitchFamily="34" charset="0"/>
-                <a:ea typeface="Be Vietnam Pro" pitchFamily="34" charset="-122"/>
-                <a:cs typeface="Be Vietnam Pro" pitchFamily="34" charset="-120"/>
-              </a:rPr>
-              <a:t>Bằng</a:t>
+              <a:rPr lang="en-US" sz="2400" dirty="0" spc="-23" kern="0">
+                <a:solidFill>
+                  <a:srgbClr val="F3EEE3"/>
+                </a:solidFill>
+                <a:latin typeface="Be Vietnam Pro" pitchFamily="34" charset="0"/>
+                <a:ea typeface="Be Vietnam Pro" pitchFamily="34" charset="-122"/>
+                <a:cs typeface="Be Vietnam Pro" pitchFamily="34" charset="-120"/>
+              </a:rPr>
+              <a:t>MRU</a:t>
             </a:r>
             <a:r>
               <a:rPr lang="en-US" sz="2400" dirty="0" spc="-2" kern="0">
@@ -11604,7 +11692,84 @@
                 <a:ea typeface="Be Vietnam Pro" pitchFamily="34" charset="-122"/>
                 <a:cs typeface="Be Vietnam Pro" pitchFamily="34" charset="-120"/>
               </a:rPr>
-              <a:t> khóa</a:t>
+              <a:t> 83</a:t>
+            </a:r>
+            <a:r>
+              <a:rPr lang="en-US" sz="2400" dirty="0" spc="1" kern="0">
+                <a:solidFill>
+                  <a:srgbClr val="F3EEE3"/>
+                </a:solidFill>
+                <a:latin typeface="Be Vietnam Pro" pitchFamily="34" charset="0"/>
+                <a:ea typeface="Be Vietnam Pro" pitchFamily="34" charset="-122"/>
+                <a:cs typeface="Be Vietnam Pro" pitchFamily="34" charset="-120"/>
+              </a:rPr>
+              <a:t> ·</a:t>
+            </a:r>
+            <a:r>
+              <a:rPr lang="en-US" sz="2400" dirty="0" spc="-8" kern="0">
+                <a:solidFill>
+                  <a:srgbClr val="F3EEE3"/>
+                </a:solidFill>
+                <a:latin typeface="Be Vietnam Pro" pitchFamily="34" charset="0"/>
+                <a:ea typeface="Be Vietnam Pro" pitchFamily="34" charset="-122"/>
+                <a:cs typeface="Be Vietnam Pro" pitchFamily="34" charset="-120"/>
+              </a:rPr>
+              <a:t> ngẫu</a:t>
+            </a:r>
+            <a:r>
+              <a:rPr lang="en-US" sz="2400" dirty="0" spc="0" kern="0">
+                <a:solidFill>
+                  <a:srgbClr val="F3EEE3"/>
+                </a:solidFill>
+                <a:latin typeface="Be Vietnam Pro" pitchFamily="34" charset="0"/>
+                <a:ea typeface="Be Vietnam Pro" pitchFamily="34" charset="-122"/>
+                <a:cs typeface="Be Vietnam Pro" pitchFamily="34" charset="-120"/>
+              </a:rPr>
+              <a:t> nhiên</a:t>
+            </a:r>
+            <a:r>
+              <a:rPr lang="en-US" sz="2400" dirty="0" spc="-20" kern="0">
+                <a:solidFill>
+                  <a:srgbClr val="F3EEE3"/>
+                </a:solidFill>
+                <a:latin typeface="Be Vietnam Pro" pitchFamily="34" charset="0"/>
+                <a:ea typeface="Be Vietnam Pro" pitchFamily="34" charset="-122"/>
+                <a:cs typeface="Be Vietnam Pro" pitchFamily="34" charset="-120"/>
+              </a:rPr>
+              <a:t> 69</a:t>
+            </a:r>
+            <a:r>
+              <a:rPr lang="en-US" sz="2400" dirty="0" spc="1" kern="0">
+                <a:solidFill>
+                  <a:srgbClr val="F3EEE3"/>
+                </a:solidFill>
+                <a:latin typeface="Be Vietnam Pro" pitchFamily="34" charset="0"/>
+                <a:ea typeface="Be Vietnam Pro" pitchFamily="34" charset="-122"/>
+                <a:cs typeface="Be Vietnam Pro" pitchFamily="34" charset="-120"/>
+              </a:rPr>
+              <a:t> ·</a:t>
+            </a:r>
+            <a:r>
+              <a:rPr lang="en-US" sz="2400" dirty="0" spc="-13" kern="0">
+                <a:solidFill>
+                  <a:srgbClr val="F3EEE3"/>
+                </a:solidFill>
+                <a:latin typeface="Be Vietnam Pro" pitchFamily="34" charset="0"/>
+                <a:ea typeface="Be Vietnam Pro" pitchFamily="34" charset="-122"/>
+                <a:cs typeface="Be Vietnam Pro" pitchFamily="34" charset="-120"/>
+              </a:rPr>
+              <a:t> LRU,</a:t>
+            </a:r>
+            <a:r>
+              <a:rPr lang="en-US" sz="2400" dirty="0" spc="0" kern="0">
+                <a:solidFill>
+                  <a:srgbClr val="F3EEE3"/>
+                </a:solidFill>
+                <a:latin typeface="Be Vietnam Pro" pitchFamily="34" charset="0"/>
+                <a:ea typeface="Be Vietnam Pro" pitchFamily="34" charset="-122"/>
+                <a:cs typeface="Be Vietnam Pro" pitchFamily="34" charset="-120"/>
+              </a:rPr>
+              <a:t> LFU,</a:t>
             </a:r>
             <a:r>
               <a:rPr lang="en-US" sz="2400" dirty="0" spc="-11" kern="0">
@@ -11615,18 +11780,29 @@
                 <a:ea typeface="Be Vietnam Pro" pitchFamily="34" charset="-122"/>
                 <a:cs typeface="Be Vietnam Pro" pitchFamily="34" charset="-120"/>
               </a:rPr>
-              <a:t> vào</a:t>
-            </a:r>
-            <a:r>
-              <a:rPr lang="en-US" sz="2400" dirty="0" spc="5" kern="0">
-                <a:solidFill>
-                  <a:srgbClr val="F3EEE3"/>
-                </a:solidFill>
-                <a:latin typeface="Be Vietnam Pro" pitchFamily="34" charset="0"/>
-                <a:ea typeface="Be Vietnam Pro" pitchFamily="34" charset="-122"/>
-                <a:cs typeface="Be Vietnam Pro" pitchFamily="34" charset="-120"/>
-              </a:rPr>
-              <a:t> trước.</a:t>
+              <a:t> FIFO,</a:t>
+            </a:r>
+            <a:r>
+              <a:rPr lang="en-US" sz="2400" dirty="0" spc="-14" kern="0">
+                <a:solidFill>
+                  <a:srgbClr val="F3EEE3"/>
+                </a:solidFill>
+                <a:latin typeface="Be Vietnam Pro" pitchFamily="34" charset="0"/>
+                <a:ea typeface="Be Vietnam Pro" pitchFamily="34" charset="-122"/>
+                <a:cs typeface="Be Vietnam Pro" pitchFamily="34" charset="-120"/>
+              </a:rPr>
+              <a:t> SLRU</a:t>
+            </a:r>
+            <a:r>
+              <a:rPr lang="en-US" sz="2400" dirty="0" spc="0" kern="0">
+                <a:solidFill>
+                  <a:srgbClr val="F3EEE3"/>
+                </a:solidFill>
+                <a:latin typeface="Be Vietnam Pro" pitchFamily="34" charset="0"/>
+                <a:ea typeface="Be Vietnam Pro" pitchFamily="34" charset="-122"/>
+                <a:cs typeface="Be Vietnam Pro" pitchFamily="34" charset="-120"/>
+              </a:rPr>
+              <a:t> 0</a:t>
             </a:r>
             <a:endParaRPr lang="en-US" sz="2400" dirty="0"/>
           </a:p>
@@ -11684,7 +11860,7 @@
               <a:buNone/>
             </a:pPr>
             <a:r>
-              <a:rPr lang="en-US" sz="2850" dirty="0" spc="-9" kern="0">
+              <a:rPr lang="en-US" sz="2850" dirty="0" spc="-16" kern="0">
                 <a:solidFill>
                   <a:srgbClr val="7C93FF"/>
                 </a:solidFill>
@@ -11692,10 +11868,10 @@
                 <a:ea typeface="Be Vietnam Pro ExtraBold" pitchFamily="34" charset="-122"/>
                 <a:cs typeface="Be Vietnam Pro ExtraBold" pitchFamily="34" charset="-120"/>
               </a:rPr>
-              <a:t>Chọn</a:t>
-            </a:r>
-            <a:r>
-              <a:rPr lang="en-US" sz="2850" dirty="0" spc="-2" kern="0">
+              <a:t>Nóng</a:t>
+            </a:r>
+            <a:r>
+              <a:rPr lang="en-US" sz="2850" dirty="0" spc="1" kern="0">
                 <a:solidFill>
                   <a:srgbClr val="7C93FF"/>
                 </a:solidFill>
@@ -11703,10 +11879,10 @@
                 <a:ea typeface="Be Vietnam Pro ExtraBold" pitchFamily="34" charset="-122"/>
                 <a:cs typeface="Be Vietnam Pro ExtraBold" pitchFamily="34" charset="-120"/>
               </a:rPr>
-              <a:t> ngẫu</a:t>
-            </a:r>
-            <a:r>
-              <a:rPr lang="en-US" sz="2850" dirty="0" spc="-3" kern="0">
+              <a:t> lẫn</a:t>
+            </a:r>
+            <a:r>
+              <a:rPr lang="en-US" sz="2850" dirty="0" spc="-13" kern="0">
                 <a:solidFill>
                   <a:srgbClr val="7C93FF"/>
                 </a:solidFill>
@@ -11714,7 +11890,18 @@
                 <a:ea typeface="Be Vietnam Pro ExtraBold" pitchFamily="34" charset="-122"/>
                 <a:cs typeface="Be Vietnam Pro ExtraBold" pitchFamily="34" charset="-120"/>
               </a:rPr>
-              <a:t> nhiên</a:t>
+              <a:t> một</a:t>
+            </a:r>
+            <a:r>
+              <a:rPr lang="en-US" sz="2850" dirty="0" spc="0" kern="0">
+                <a:solidFill>
+                  <a:srgbClr val="7C93FF"/>
+                </a:solidFill>
+                <a:latin typeface="Be Vietnam Pro ExtraBold" pitchFamily="34" charset="0"/>
+                <a:ea typeface="Be Vietnam Pro ExtraBold" pitchFamily="34" charset="-122"/>
+                <a:cs typeface="Be Vietnam Pro ExtraBold" pitchFamily="34" charset="-120"/>
+              </a:rPr>
+              <a:t> lần</a:t>
             </a:r>
             <a:endParaRPr lang="en-US" sz="2850" dirty="0"/>
           </a:p>
@@ -11745,26 +11932,92 @@
               <a:buNone/>
             </a:pPr>
             <a:r>
-              <a:rPr lang="en-US" sz="2400" dirty="0" spc="4" kern="0">
-                <a:solidFill>
-                  <a:srgbClr val="F3EEE3"/>
-                </a:solidFill>
-                <a:latin typeface="Be Vietnam Pro" pitchFamily="34" charset="0"/>
-                <a:ea typeface="Be Vietnam Pro" pitchFamily="34" charset="-122"/>
-                <a:cs typeface="Be Vietnam Pro" pitchFamily="34" charset="-120"/>
-              </a:rPr>
-              <a:t>Bộ</a:t>
-            </a:r>
-            <a:r>
-              <a:rPr lang="en-US" sz="2400" dirty="0" spc="-2" kern="0">
-                <a:solidFill>
-                  <a:srgbClr val="F3EEE3"/>
-                </a:solidFill>
-                <a:latin typeface="Be Vietnam Pro" pitchFamily="34" charset="0"/>
-                <a:ea typeface="Be Vietnam Pro" pitchFamily="34" charset="-122"/>
-                <a:cs typeface="Be Vietnam Pro" pitchFamily="34" charset="-120"/>
-              </a:rPr>
-              <a:t> sinh</a:t>
+              <a:rPr lang="en-US" sz="2400" dirty="0" spc="-1" kern="0">
+                <a:solidFill>
+                  <a:srgbClr val="F3EEE3"/>
+                </a:solidFill>
+                <a:latin typeface="Be Vietnam Pro" pitchFamily="34" charset="0"/>
+                <a:ea typeface="Be Vietnam Pro" pitchFamily="34" charset="-122"/>
+                <a:cs typeface="Be Vietnam Pro" pitchFamily="34" charset="-120"/>
+              </a:rPr>
+              <a:t>LFU,</a:t>
+            </a:r>
+            <a:r>
+              <a:rPr lang="en-US" sz="2400" dirty="0" spc="-13" kern="0">
+                <a:solidFill>
+                  <a:srgbClr val="F3EEE3"/>
+                </a:solidFill>
+                <a:latin typeface="Be Vietnam Pro" pitchFamily="34" charset="0"/>
+                <a:ea typeface="Be Vietnam Pro" pitchFamily="34" charset="-122"/>
+                <a:cs typeface="Be Vietnam Pro" pitchFamily="34" charset="-120"/>
+              </a:rPr>
+              <a:t> SLRU</a:t>
+            </a:r>
+            <a:r>
+              <a:rPr lang="en-US" sz="2400" dirty="0" spc="-41" kern="0">
+                <a:solidFill>
+                  <a:srgbClr val="F3EEE3"/>
+                </a:solidFill>
+                <a:latin typeface="Be Vietnam Pro" pitchFamily="34" charset="0"/>
+                <a:ea typeface="Be Vietnam Pro" pitchFamily="34" charset="-122"/>
+                <a:cs typeface="Be Vietnam Pro" pitchFamily="34" charset="-120"/>
+              </a:rPr>
+              <a:t> 70</a:t>
+            </a:r>
+            <a:r>
+              <a:rPr lang="en-US" sz="2400" dirty="0" spc="1" kern="0">
+                <a:solidFill>
+                  <a:srgbClr val="F3EEE3"/>
+                </a:solidFill>
+                <a:latin typeface="Be Vietnam Pro" pitchFamily="34" charset="0"/>
+                <a:ea typeface="Be Vietnam Pro" pitchFamily="34" charset="-122"/>
+                <a:cs typeface="Be Vietnam Pro" pitchFamily="34" charset="-120"/>
+              </a:rPr>
+              <a:t> ·</a:t>
+            </a:r>
+            <a:r>
+              <a:rPr lang="en-US" sz="2400" dirty="0" spc="-17" kern="0">
+                <a:solidFill>
+                  <a:srgbClr val="F3EEE3"/>
+                </a:solidFill>
+                <a:latin typeface="Be Vietnam Pro" pitchFamily="34" charset="0"/>
+                <a:ea typeface="Be Vietnam Pro" pitchFamily="34" charset="-122"/>
+                <a:cs typeface="Be Vietnam Pro" pitchFamily="34" charset="-120"/>
+              </a:rPr>
+              <a:t> LRU</a:t>
+            </a:r>
+            <a:r>
+              <a:rPr lang="en-US" sz="2400" dirty="0" spc="1" kern="0">
+                <a:solidFill>
+                  <a:srgbClr val="F3EEE3"/>
+                </a:solidFill>
+                <a:latin typeface="Be Vietnam Pro" pitchFamily="34" charset="0"/>
+                <a:ea typeface="Be Vietnam Pro" pitchFamily="34" charset="-122"/>
+                <a:cs typeface="Be Vietnam Pro" pitchFamily="34" charset="-120"/>
+              </a:rPr>
+              <a:t> 64</a:t>
+            </a:r>
+            <a:r>
+              <a:rPr lang="en-US" sz="2400" dirty="0" spc="0" kern="0">
+                <a:solidFill>
+                  <a:srgbClr val="F3EEE3"/>
+                </a:solidFill>
+                <a:latin typeface="Be Vietnam Pro" pitchFamily="34" charset="0"/>
+                <a:ea typeface="Be Vietnam Pro" pitchFamily="34" charset="-122"/>
+                <a:cs typeface="Be Vietnam Pro" pitchFamily="34" charset="-120"/>
+              </a:rPr>
+              <a:t> ·</a:t>
+            </a:r>
+            <a:r>
+              <a:rPr lang="en-US" sz="2400" dirty="0" spc="-17" kern="0">
+                <a:solidFill>
+                  <a:srgbClr val="F3EEE3"/>
+                </a:solidFill>
+                <a:latin typeface="Be Vietnam Pro" pitchFamily="34" charset="0"/>
+                <a:ea typeface="Be Vietnam Pro" pitchFamily="34" charset="-122"/>
+                <a:cs typeface="Be Vietnam Pro" pitchFamily="34" charset="-120"/>
+              </a:rPr>
+              <a:t> MRU</a:t>
             </a:r>
             <a:r>
               <a:rPr lang="en-US" sz="2400" dirty="0" spc="-8" kern="0">
@@ -11775,7 +12028,7 @@
                 <a:ea typeface="Be Vietnam Pro" pitchFamily="34" charset="-122"/>
                 <a:cs typeface="Be Vietnam Pro" pitchFamily="34" charset="-120"/>
               </a:rPr>
-              <a:t> số</a:t>
+              <a:t> gần</a:t>
             </a:r>
             <a:r>
               <a:rPr lang="en-US" sz="2400" dirty="0" spc="0" kern="0">
@@ -11786,84 +12039,7 @@
                 <a:ea typeface="Be Vietnam Pro" pitchFamily="34" charset="-122"/>
                 <a:cs typeface="Be Vietnam Pro" pitchFamily="34" charset="-120"/>
               </a:rPr>
-              <a:t> cố</a:t>
-            </a:r>
-            <a:r>
-              <a:rPr lang="en-US" sz="2400" dirty="0" spc="17" kern="0">
-                <a:solidFill>
-                  <a:srgbClr val="F3EEE3"/>
-                </a:solidFill>
-                <a:latin typeface="Be Vietnam Pro" pitchFamily="34" charset="0"/>
-                <a:ea typeface="Be Vietnam Pro" pitchFamily="34" charset="-122"/>
-                <a:cs typeface="Be Vietnam Pro" pitchFamily="34" charset="-120"/>
-              </a:rPr>
-              <a:t> định,</a:t>
-            </a:r>
-            <a:r>
-              <a:rPr lang="en-US" sz="2400" dirty="0" spc="-7" kern="0">
-                <a:solidFill>
-                  <a:srgbClr val="F3EEE3"/>
-                </a:solidFill>
-                <a:latin typeface="Be Vietnam Pro" pitchFamily="34" charset="0"/>
-                <a:ea typeface="Be Vietnam Pro" pitchFamily="34" charset="-122"/>
-                <a:cs typeface="Be Vietnam Pro" pitchFamily="34" charset="-120"/>
-              </a:rPr>
-              <a:t> chạy</a:t>
-            </a:r>
-            <a:r>
-              <a:rPr lang="en-US" sz="2400" dirty="0" spc="0" kern="0">
-                <a:solidFill>
-                  <a:srgbClr val="F3EEE3"/>
-                </a:solidFill>
-                <a:latin typeface="Be Vietnam Pro" pitchFamily="34" charset="0"/>
-                <a:ea typeface="Be Vietnam Pro" pitchFamily="34" charset="-122"/>
-                <a:cs typeface="Be Vietnam Pro" pitchFamily="34" charset="-120"/>
-              </a:rPr>
-              <a:t> lại</a:t>
-            </a:r>
-            <a:r>
-              <a:rPr lang="en-US" sz="2400" dirty="0" spc="1" kern="0">
-                <a:solidFill>
-                  <a:srgbClr val="F3EEE3"/>
-                </a:solidFill>
-                <a:latin typeface="Be Vietnam Pro" pitchFamily="34" charset="0"/>
-                <a:ea typeface="Be Vietnam Pro" pitchFamily="34" charset="-122"/>
-                <a:cs typeface="Be Vietnam Pro" pitchFamily="34" charset="-120"/>
-              </a:rPr>
-              <a:t> cho</a:t>
-            </a:r>
-            <a:r>
-              <a:rPr lang="en-US" sz="2400" dirty="0" spc="2" kern="0">
-                <a:solidFill>
-                  <a:srgbClr val="F3EEE3"/>
-                </a:solidFill>
-                <a:latin typeface="Be Vietnam Pro" pitchFamily="34" charset="0"/>
-                <a:ea typeface="Be Vietnam Pro" pitchFamily="34" charset="-122"/>
-                <a:cs typeface="Be Vietnam Pro" pitchFamily="34" charset="-120"/>
-              </a:rPr>
-              <a:t> cùng</a:t>
-            </a:r>
-            <a:r>
-              <a:rPr lang="en-US" sz="2400" dirty="0" spc="-34" kern="0">
-                <a:solidFill>
-                  <a:srgbClr val="F3EEE3"/>
-                </a:solidFill>
-                <a:latin typeface="Be Vietnam Pro" pitchFamily="34" charset="0"/>
-                <a:ea typeface="Be Vietnam Pro" pitchFamily="34" charset="-122"/>
-                <a:cs typeface="Be Vietnam Pro" pitchFamily="34" charset="-120"/>
-              </a:rPr>
-              <a:t> kết</a:t>
-            </a:r>
-            <a:r>
-              <a:rPr lang="en-US" sz="2400" dirty="0" spc="1" kern="0">
-                <a:solidFill>
-                  <a:srgbClr val="F3EEE3"/>
-                </a:solidFill>
-                <a:latin typeface="Be Vietnam Pro" pitchFamily="34" charset="0"/>
-                <a:ea typeface="Be Vietnam Pro" pitchFamily="34" charset="-122"/>
-                <a:cs typeface="Be Vietnam Pro" pitchFamily="34" charset="-120"/>
-              </a:rPr>
-              <a:t> quả.</a:t>
+              <a:t> 1</a:t>
             </a:r>
             <a:endParaRPr lang="en-US" sz="2400" dirty="0"/>
           </a:p>
@@ -11921,7 +12097,7 @@
               <a:buNone/>
             </a:pPr>
             <a:r>
-              <a:rPr lang="en-US" sz="2850" dirty="0" spc="-1" kern="0">
+              <a:rPr lang="en-US" sz="2850" dirty="0" spc="4" kern="0">
                 <a:solidFill>
                   <a:srgbClr val="FFB454"/>
                 </a:solidFill>
@@ -11929,10 +12105,10 @@
                 <a:ea typeface="Be Vietnam Pro ExtraBold" pitchFamily="34" charset="-122"/>
                 <a:cs typeface="Be Vietnam Pro ExtraBold" pitchFamily="34" charset="-120"/>
               </a:rPr>
-              <a:t>Phân</a:t>
-            </a:r>
-            <a:r>
-              <a:rPr lang="en-US" sz="2850" dirty="0" spc="0" kern="0">
+              <a:t>Cách</a:t>
+            </a:r>
+            <a:r>
+              <a:rPr lang="en-US" sz="2850" dirty="0" spc="-5" kern="0">
                 <a:solidFill>
                   <a:srgbClr val="FFB454"/>
                 </a:solidFill>
@@ -11940,10 +12116,10 @@
                 <a:ea typeface="Be Vietnam Pro ExtraBold" pitchFamily="34" charset="-122"/>
                 <a:cs typeface="Be Vietnam Pro ExtraBold" pitchFamily="34" charset="-120"/>
               </a:rPr>
-              <a:t> bố</a:t>
-            </a:r>
-            <a:r>
-              <a:rPr lang="en-US" sz="2850" dirty="0" spc="-9" kern="0">
+              <a:t> mô</a:t>
+            </a:r>
+            <a:r>
+              <a:rPr lang="en-US" sz="2850" dirty="0" spc="-13" kern="0">
                 <a:solidFill>
                   <a:srgbClr val="FFB454"/>
                 </a:solidFill>
@@ -11951,7 +12127,7 @@
                 <a:ea typeface="Be Vietnam Pro ExtraBold" pitchFamily="34" charset="-122"/>
                 <a:cs typeface="Be Vietnam Pro ExtraBold" pitchFamily="34" charset="-120"/>
               </a:rPr>
-              <a:t> Zipf</a:t>
+              <a:t> phỏng</a:t>
             </a:r>
             <a:endParaRPr lang="en-US" sz="2850" dirty="0"/>
           </a:p>
@@ -11982,6 +12158,28 @@
               <a:buNone/>
             </a:pPr>
             <a:r>
+              <a:rPr lang="en-US" sz="2400" dirty="0" spc="-1" kern="0">
+                <a:solidFill>
+                  <a:srgbClr val="F3EEE3"/>
+                </a:solidFill>
+                <a:latin typeface="Be Vietnam Pro" pitchFamily="34" charset="0"/>
+                <a:ea typeface="Be Vietnam Pro" pitchFamily="34" charset="-122"/>
+                <a:cs typeface="Be Vietnam Pro" pitchFamily="34" charset="-120"/>
+              </a:rPr>
+              <a:t>Mỗi chính</a:t>
+            </a:r>
+            <a:r>
+              <a:rPr lang="en-US" sz="2400" dirty="0" spc="-5" kern="0">
+                <a:solidFill>
+                  <a:srgbClr val="F3EEE3"/>
+                </a:solidFill>
+                <a:latin typeface="Be Vietnam Pro" pitchFamily="34" charset="0"/>
+                <a:ea typeface="Be Vietnam Pro" pitchFamily="34" charset="-122"/>
+                <a:cs typeface="Be Vietnam Pro" pitchFamily="34" charset="-120"/>
+              </a:rPr>
+              <a:t> sách</a:t>
+            </a:r>
+            <a:r>
               <a:rPr lang="en-US" sz="2400" dirty="0" spc="2" kern="0">
                 <a:solidFill>
                   <a:srgbClr val="F3EEE3"/>
@@ -11990,29 +12188,40 @@
                 <a:ea typeface="Be Vietnam Pro" pitchFamily="34" charset="-122"/>
                 <a:cs typeface="Be Vietnam Pro" pitchFamily="34" charset="-120"/>
               </a:rPr>
-              <a:t>Mũ</a:t>
-            </a:r>
-            <a:r>
-              <a:rPr lang="en-US" sz="2400" dirty="0" spc="0" kern="0">
-                <a:solidFill>
-                  <a:srgbClr val="F3EEE3"/>
-                </a:solidFill>
-                <a:latin typeface="Be Vietnam Pro" pitchFamily="34" charset="0"/>
-                <a:ea typeface="Be Vietnam Pro" pitchFamily="34" charset="-122"/>
-                <a:cs typeface="Be Vietnam Pro" pitchFamily="34" charset="-120"/>
-              </a:rPr>
-              <a:t> 1</a:t>
-            </a:r>
-            <a:r>
-              <a:rPr lang="en-US" sz="2400" dirty="0" spc="-18" kern="0">
-                <a:solidFill>
-                  <a:srgbClr val="F3EEE3"/>
-                </a:solidFill>
-                <a:latin typeface="Be Vietnam Pro" pitchFamily="34" charset="0"/>
-                <a:ea typeface="Be Vietnam Pro" pitchFamily="34" charset="-122"/>
-                <a:cs typeface="Be Vietnam Pro" pitchFamily="34" charset="-120"/>
-              </a:rPr>
-              <a:t> trên</a:t>
+              <a:t> là</a:t>
+            </a:r>
+            <a:r>
+              <a:rPr lang="en-US" sz="2400" dirty="0" spc="-3" kern="0">
+                <a:solidFill>
+                  <a:srgbClr val="F3EEE3"/>
+                </a:solidFill>
+                <a:latin typeface="Be Vietnam Pro" pitchFamily="34" charset="0"/>
+                <a:ea typeface="Be Vietnam Pro" pitchFamily="34" charset="-122"/>
+                <a:cs typeface="Be Vietnam Pro" pitchFamily="34" charset="-120"/>
+              </a:rPr>
+              <a:t> một</a:t>
+            </a:r>
+            <a:r>
+              <a:rPr lang="en-US" sz="2400" dirty="0" spc="3" kern="0">
+                <a:solidFill>
+                  <a:srgbClr val="F3EEE3"/>
+                </a:solidFill>
+                <a:latin typeface="Be Vietnam Pro" pitchFamily="34" charset="0"/>
+                <a:ea typeface="Be Vietnam Pro" pitchFamily="34" charset="-122"/>
+                <a:cs typeface="Be Vietnam Pro" pitchFamily="34" charset="-120"/>
+              </a:rPr>
+              <a:t> hàm</a:t>
+            </a:r>
+            <a:r>
+              <a:rPr lang="en-US" sz="2400" dirty="0" spc="1" kern="0">
+                <a:solidFill>
+                  <a:srgbClr val="F3EEE3"/>
+                </a:solidFill>
+                <a:latin typeface="Be Vietnam Pro" pitchFamily="34" charset="0"/>
+                <a:ea typeface="Be Vietnam Pro" pitchFamily="34" charset="-122"/>
+                <a:cs typeface="Be Vietnam Pro" pitchFamily="34" charset="-120"/>
+              </a:rPr>
+              <a:t> nhận</a:t>
             </a:r>
             <a:r>
               <a:rPr lang="en-US" sz="2400" dirty="0" spc="-1" kern="0">
@@ -12023,18 +12232,84 @@
                 <a:ea typeface="Be Vietnam Pro" pitchFamily="34" charset="-122"/>
                 <a:cs typeface="Be Vietnam Pro" pitchFamily="34" charset="-120"/>
               </a:rPr>
-              <a:t> 1.000</a:t>
-            </a:r>
-            <a:r>
-              <a:rPr lang="en-US" sz="2400" dirty="0" spc="-2" kern="0">
-                <a:solidFill>
-                  <a:srgbClr val="F3EEE3"/>
-                </a:solidFill>
-                <a:latin typeface="Be Vietnam Pro" pitchFamily="34" charset="0"/>
-                <a:ea typeface="Be Vietnam Pro" pitchFamily="34" charset="-122"/>
-                <a:cs typeface="Be Vietnam Pro" pitchFamily="34" charset="-120"/>
-              </a:rPr>
-              <a:t> khóa.</a:t>
+              <a:t> chuỗi</a:t>
+            </a:r>
+            <a:r>
+              <a:rPr lang="en-US" sz="2400" dirty="0" spc="-3" kern="0">
+                <a:solidFill>
+                  <a:srgbClr val="F3EEE3"/>
+                </a:solidFill>
+                <a:latin typeface="Be Vietnam Pro" pitchFamily="34" charset="0"/>
+                <a:ea typeface="Be Vietnam Pro" pitchFamily="34" charset="-122"/>
+                <a:cs typeface="Be Vietnam Pro" pitchFamily="34" charset="-120"/>
+              </a:rPr>
+              <a:t> khóa</a:t>
+            </a:r>
+            <a:r>
+              <a:rPr lang="en-US" sz="2400" dirty="0" spc="-15" kern="0">
+                <a:solidFill>
+                  <a:srgbClr val="F3EEE3"/>
+                </a:solidFill>
+                <a:latin typeface="Be Vietnam Pro" pitchFamily="34" charset="0"/>
+                <a:ea typeface="Be Vietnam Pro" pitchFamily="34" charset="-122"/>
+                <a:cs typeface="Be Vietnam Pro" pitchFamily="34" charset="-120"/>
+              </a:rPr>
+              <a:t> và</a:t>
+            </a:r>
+            <a:r>
+              <a:rPr lang="en-US" sz="2400" dirty="0" spc="9" kern="0">
+                <a:solidFill>
+                  <a:srgbClr val="F3EEE3"/>
+                </a:solidFill>
+                <a:latin typeface="Be Vietnam Pro" pitchFamily="34" charset="0"/>
+                <a:ea typeface="Be Vietnam Pro" pitchFamily="34" charset="-122"/>
+                <a:cs typeface="Be Vietnam Pro" pitchFamily="34" charset="-120"/>
+              </a:rPr>
+              <a:t> sức</a:t>
+            </a:r>
+            <a:r>
+              <a:rPr lang="en-US" sz="2400" dirty="0" spc="7" kern="0">
+                <a:solidFill>
+                  <a:srgbClr val="F3EEE3"/>
+                </a:solidFill>
+                <a:latin typeface="Be Vietnam Pro" pitchFamily="34" charset="0"/>
+                <a:ea typeface="Be Vietnam Pro" pitchFamily="34" charset="-122"/>
+                <a:cs typeface="Be Vietnam Pro" pitchFamily="34" charset="-120"/>
+              </a:rPr>
+              <a:t> chứa,</a:t>
+            </a:r>
+            <a:r>
+              <a:rPr lang="en-US" sz="2400" dirty="0" spc="14" kern="0">
+                <a:solidFill>
+                  <a:srgbClr val="F3EEE3"/>
+                </a:solidFill>
+                <a:latin typeface="Be Vietnam Pro" pitchFamily="34" charset="0"/>
+                <a:ea typeface="Be Vietnam Pro" pitchFamily="34" charset="-122"/>
+                <a:cs typeface="Be Vietnam Pro" pitchFamily="34" charset="-120"/>
+              </a:rPr>
+              <a:t> đếm</a:t>
+            </a:r>
+            <a:r>
+              <a:rPr lang="en-US" sz="2400" dirty="0" spc="8" kern="0">
+                <a:solidFill>
+                  <a:srgbClr val="F3EEE3"/>
+                </a:solidFill>
+                <a:latin typeface="Be Vietnam Pro" pitchFamily="34" charset="0"/>
+                <a:ea typeface="Be Vietnam Pro" pitchFamily="34" charset="-122"/>
+                <a:cs typeface="Be Vietnam Pro" pitchFamily="34" charset="-120"/>
+              </a:rPr>
+              <a:t> lượt</a:t>
+            </a:r>
+            <a:r>
+              <a:rPr lang="en-US" sz="2400" dirty="0" spc="2" kern="0">
+                <a:solidFill>
+                  <a:srgbClr val="F3EEE3"/>
+                </a:solidFill>
+                <a:latin typeface="Be Vietnam Pro" pitchFamily="34" charset="0"/>
+                <a:ea typeface="Be Vietnam Pro" pitchFamily="34" charset="-122"/>
+                <a:cs typeface="Be Vietnam Pro" pitchFamily="34" charset="-120"/>
+              </a:rPr>
+              <a:t> trúng.</a:t>
             </a:r>
             <a:endParaRPr lang="en-US" sz="2400" dirty="0"/>
           </a:p>

</xml_diff>

<commit_message>
Slides: state the simulation inputs (sd-06-010), keep bullets within ten words (sd-13-011, sd-13-020)
Co-Authored-By: Claude Sonnet 5.5 <noreply@anthropic.com>
Claude-Session: https://claude.ai/code/session_01EhxTYrCJpuk4mcqCLwPdds
</commit_message>
<xml_diff>
--- a/system-design-101/vi/lessons/sd-06-010/slides/sd-06-010.pptx
+++ b/system-design-101/vi/lessons/sd-06-010/slides/sd-06-010.pptx
@@ -12158,6 +12158,28 @@
               <a:buNone/>
             </a:pPr>
             <a:r>
+              <a:rPr lang="en-US" sz="2400" dirty="0" spc="4" kern="0">
+                <a:solidFill>
+                  <a:srgbClr val="F3EEE3"/>
+                </a:solidFill>
+                <a:latin typeface="Be Vietnam Pro" pitchFamily="34" charset="0"/>
+                <a:ea typeface="Be Vietnam Pro" pitchFamily="34" charset="-122"/>
+                <a:cs typeface="Be Vietnam Pro" pitchFamily="34" charset="-120"/>
+              </a:rPr>
+              <a:t>Bộ</a:t>
+            </a:r>
+            <a:r>
+              <a:rPr lang="en-US" sz="2400" dirty="0" spc="14" kern="0">
+                <a:solidFill>
+                  <a:srgbClr val="F3EEE3"/>
+                </a:solidFill>
+                <a:latin typeface="Be Vietnam Pro" pitchFamily="34" charset="0"/>
+                <a:ea typeface="Be Vietnam Pro" pitchFamily="34" charset="-122"/>
+                <a:cs typeface="Be Vietnam Pro" pitchFamily="34" charset="-120"/>
+              </a:rPr>
+              <a:t> đệm</a:t>
+            </a:r>
+            <a:r>
               <a:rPr lang="en-US" sz="2400" dirty="0" spc="-1" kern="0">
                 <a:solidFill>
                   <a:srgbClr val="F3EEE3"/>
@@ -12166,18 +12188,51 @@
                 <a:ea typeface="Be Vietnam Pro" pitchFamily="34" charset="-122"/>
                 <a:cs typeface="Be Vietnam Pro" pitchFamily="34" charset="-120"/>
               </a:rPr>
-              <a:t>Mỗi chính</a:t>
-            </a:r>
-            <a:r>
-              <a:rPr lang="en-US" sz="2400" dirty="0" spc="-5" kern="0">
-                <a:solidFill>
-                  <a:srgbClr val="F3EEE3"/>
-                </a:solidFill>
-                <a:latin typeface="Be Vietnam Pro" pitchFamily="34" charset="0"/>
-                <a:ea typeface="Be Vietnam Pro" pitchFamily="34" charset="-122"/>
-                <a:cs typeface="Be Vietnam Pro" pitchFamily="34" charset="-120"/>
-              </a:rPr>
-              <a:t> sách</a:t>
+              <a:t> 100</a:t>
+            </a:r>
+            <a:r>
+              <a:rPr lang="en-US" sz="2400" dirty="0" spc="-2" kern="0">
+                <a:solidFill>
+                  <a:srgbClr val="F3EEE3"/>
+                </a:solidFill>
+                <a:latin typeface="Be Vietnam Pro" pitchFamily="34" charset="0"/>
+                <a:ea typeface="Be Vietnam Pro" pitchFamily="34" charset="-122"/>
+                <a:cs typeface="Be Vietnam Pro" pitchFamily="34" charset="-120"/>
+              </a:rPr>
+              <a:t> khóa,</a:t>
+            </a:r>
+            <a:r>
+              <a:rPr lang="en-US" sz="2400" dirty="0" spc="-1" kern="0">
+                <a:solidFill>
+                  <a:srgbClr val="F3EEE3"/>
+                </a:solidFill>
+                <a:latin typeface="Be Vietnam Pro" pitchFamily="34" charset="0"/>
+                <a:ea typeface="Be Vietnam Pro" pitchFamily="34" charset="-122"/>
+                <a:cs typeface="Be Vietnam Pro" pitchFamily="34" charset="-120"/>
+              </a:rPr>
+              <a:t> 100.000</a:t>
+            </a:r>
+            <a:r>
+              <a:rPr lang="en-US" sz="2400" dirty="0" spc="7" kern="0">
+                <a:solidFill>
+                  <a:srgbClr val="F3EEE3"/>
+                </a:solidFill>
+                <a:latin typeface="Be Vietnam Pro" pitchFamily="34" charset="0"/>
+                <a:ea typeface="Be Vietnam Pro" pitchFamily="34" charset="-122"/>
+                <a:cs typeface="Be Vietnam Pro" pitchFamily="34" charset="-120"/>
+              </a:rPr>
+              <a:t> lượt</a:t>
+            </a:r>
+            <a:r>
+              <a:rPr lang="en-US" sz="2400" dirty="0" spc="0" kern="0">
+                <a:solidFill>
+                  <a:srgbClr val="F3EEE3"/>
+                </a:solidFill>
+                <a:latin typeface="Be Vietnam Pro" pitchFamily="34" charset="0"/>
+                <a:ea typeface="Be Vietnam Pro" pitchFamily="34" charset="-122"/>
+                <a:cs typeface="Be Vietnam Pro" pitchFamily="34" charset="-120"/>
+              </a:rPr>
+              <a:t> truy</a:t>
             </a:r>
             <a:r>
               <a:rPr lang="en-US" sz="2400" dirty="0" spc="2" kern="0">
@@ -12188,29 +12243,7 @@
                 <a:ea typeface="Be Vietnam Pro" pitchFamily="34" charset="-122"/>
                 <a:cs typeface="Be Vietnam Pro" pitchFamily="34" charset="-120"/>
               </a:rPr>
-              <a:t> là</a:t>
-            </a:r>
-            <a:r>
-              <a:rPr lang="en-US" sz="2400" dirty="0" spc="-3" kern="0">
-                <a:solidFill>
-                  <a:srgbClr val="F3EEE3"/>
-                </a:solidFill>
-                <a:latin typeface="Be Vietnam Pro" pitchFamily="34" charset="0"/>
-                <a:ea typeface="Be Vietnam Pro" pitchFamily="34" charset="-122"/>
-                <a:cs typeface="Be Vietnam Pro" pitchFamily="34" charset="-120"/>
-              </a:rPr>
-              <a:t> một</a:t>
-            </a:r>
-            <a:r>
-              <a:rPr lang="en-US" sz="2400" dirty="0" spc="3" kern="0">
-                <a:solidFill>
-                  <a:srgbClr val="F3EEE3"/>
-                </a:solidFill>
-                <a:latin typeface="Be Vietnam Pro" pitchFamily="34" charset="0"/>
-                <a:ea typeface="Be Vietnam Pro" pitchFamily="34" charset="-122"/>
-                <a:cs typeface="Be Vietnam Pro" pitchFamily="34" charset="-120"/>
-              </a:rPr>
-              <a:t> hàm</a:t>
+              <a:t> cập</a:t>
             </a:r>
             <a:r>
               <a:rPr lang="en-US" sz="2400" dirty="0" spc="1" kern="0">
@@ -12221,95 +12254,18 @@
                 <a:ea typeface="Be Vietnam Pro" pitchFamily="34" charset="-122"/>
                 <a:cs typeface="Be Vietnam Pro" pitchFamily="34" charset="-120"/>
               </a:rPr>
-              <a:t> nhận</a:t>
-            </a:r>
-            <a:r>
-              <a:rPr lang="en-US" sz="2400" dirty="0" spc="-1" kern="0">
-                <a:solidFill>
-                  <a:srgbClr val="F3EEE3"/>
-                </a:solidFill>
-                <a:latin typeface="Be Vietnam Pro" pitchFamily="34" charset="0"/>
-                <a:ea typeface="Be Vietnam Pro" pitchFamily="34" charset="-122"/>
-                <a:cs typeface="Be Vietnam Pro" pitchFamily="34" charset="-120"/>
-              </a:rPr>
-              <a:t> chuỗi</a:t>
-            </a:r>
-            <a:r>
-              <a:rPr lang="en-US" sz="2400" dirty="0" spc="-3" kern="0">
-                <a:solidFill>
-                  <a:srgbClr val="F3EEE3"/>
-                </a:solidFill>
-                <a:latin typeface="Be Vietnam Pro" pitchFamily="34" charset="0"/>
-                <a:ea typeface="Be Vietnam Pro" pitchFamily="34" charset="-122"/>
-                <a:cs typeface="Be Vietnam Pro" pitchFamily="34" charset="-120"/>
-              </a:rPr>
-              <a:t> khóa</a:t>
-            </a:r>
-            <a:r>
-              <a:rPr lang="en-US" sz="2400" dirty="0" spc="-15" kern="0">
-                <a:solidFill>
-                  <a:srgbClr val="F3EEE3"/>
-                </a:solidFill>
-                <a:latin typeface="Be Vietnam Pro" pitchFamily="34" charset="0"/>
-                <a:ea typeface="Be Vietnam Pro" pitchFamily="34" charset="-122"/>
-                <a:cs typeface="Be Vietnam Pro" pitchFamily="34" charset="-120"/>
-              </a:rPr>
-              <a:t> và</a:t>
-            </a:r>
-            <a:r>
-              <a:rPr lang="en-US" sz="2400" dirty="0" spc="9" kern="0">
-                <a:solidFill>
-                  <a:srgbClr val="F3EEE3"/>
-                </a:solidFill>
-                <a:latin typeface="Be Vietnam Pro" pitchFamily="34" charset="0"/>
-                <a:ea typeface="Be Vietnam Pro" pitchFamily="34" charset="-122"/>
-                <a:cs typeface="Be Vietnam Pro" pitchFamily="34" charset="-120"/>
-              </a:rPr>
-              <a:t> sức</a:t>
-            </a:r>
-            <a:r>
-              <a:rPr lang="en-US" sz="2400" dirty="0" spc="7" kern="0">
-                <a:solidFill>
-                  <a:srgbClr val="F3EEE3"/>
-                </a:solidFill>
-                <a:latin typeface="Be Vietnam Pro" pitchFamily="34" charset="0"/>
-                <a:ea typeface="Be Vietnam Pro" pitchFamily="34" charset="-122"/>
-                <a:cs typeface="Be Vietnam Pro" pitchFamily="34" charset="-120"/>
-              </a:rPr>
-              <a:t> chứa,</a:t>
-            </a:r>
-            <a:r>
-              <a:rPr lang="en-US" sz="2400" dirty="0" spc="14" kern="0">
-                <a:solidFill>
-                  <a:srgbClr val="F3EEE3"/>
-                </a:solidFill>
-                <a:latin typeface="Be Vietnam Pro" pitchFamily="34" charset="0"/>
-                <a:ea typeface="Be Vietnam Pro" pitchFamily="34" charset="-122"/>
-                <a:cs typeface="Be Vietnam Pro" pitchFamily="34" charset="-120"/>
-              </a:rPr>
-              <a:t> đếm</a:t>
-            </a:r>
-            <a:r>
-              <a:rPr lang="en-US" sz="2400" dirty="0" spc="8" kern="0">
-                <a:solidFill>
-                  <a:srgbClr val="F3EEE3"/>
-                </a:solidFill>
-                <a:latin typeface="Be Vietnam Pro" pitchFamily="34" charset="0"/>
-                <a:ea typeface="Be Vietnam Pro" pitchFamily="34" charset="-122"/>
-                <a:cs typeface="Be Vietnam Pro" pitchFamily="34" charset="-120"/>
-              </a:rPr>
-              <a:t> lượt</a:t>
-            </a:r>
-            <a:r>
-              <a:rPr lang="en-US" sz="2400" dirty="0" spc="2" kern="0">
-                <a:solidFill>
-                  <a:srgbClr val="F3EEE3"/>
-                </a:solidFill>
-                <a:latin typeface="Be Vietnam Pro" pitchFamily="34" charset="0"/>
-                <a:ea typeface="Be Vietnam Pro" pitchFamily="34" charset="-122"/>
-                <a:cs typeface="Be Vietnam Pro" pitchFamily="34" charset="-120"/>
-              </a:rPr>
-              <a:t> trúng.</a:t>
+              <a:t> mỗi</a:t>
+            </a:r>
+            <a:r>
+              <a:rPr lang="en-US" sz="2400" dirty="0" spc="-2" kern="0">
+                <a:solidFill>
+                  <a:srgbClr val="F3EEE3"/>
+                </a:solidFill>
+                <a:latin typeface="Be Vietnam Pro" pitchFamily="34" charset="0"/>
+                <a:ea typeface="Be Vietnam Pro" pitchFamily="34" charset="-122"/>
+                <a:cs typeface="Be Vietnam Pro" pitchFamily="34" charset="-120"/>
+              </a:rPr>
+              <a:t> kiểu.</a:t>
             </a:r>
             <a:endParaRPr lang="en-US" sz="2400" dirty="0"/>
           </a:p>

</xml_diff>

<commit_message>
Slides: slide titles at 92 px or more on every deck
Co-Authored-By: Claude Sonnet 5.5 <noreply@anthropic.com>
Claude-Session: https://claude.ai/code/session_01EhxTYrCJpuk4mcqCLwPdds
</commit_message>
<xml_diff>
--- a/system-design-101/vi/lessons/sd-06-010/slides/sd-06-010.pptx
+++ b/system-design-101/vi/lessons/sd-06-010/slides/sd-06-010.pptx
@@ -3803,7 +3803,7 @@
               <a:buNone/>
             </a:pPr>
             <a:r>
-              <a:rPr lang="en-US" sz="6300" dirty="0" spc="-1" kern="0">
+              <a:rPr lang="en-US" sz="6900" dirty="0" spc="1" kern="0">
                 <a:solidFill>
                   <a:srgbClr val="14161C"/>
                 </a:solidFill>
@@ -3811,10 +3811,10 @@
                 <a:ea typeface="Bricolage Grotesque ExtraBold" pitchFamily="34" charset="-122"/>
                 <a:cs typeface="Bricolage Grotesque ExtraBold" pitchFamily="34" charset="-120"/>
               </a:rPr>
-              <a:t>Giải</a:t>
-            </a:r>
-            <a:r>
-              <a:rPr lang="en-US" sz="6300" dirty="0" spc="2" kern="0">
+              <a:t>Giải thích</a:t>
+            </a:r>
+            <a:r>
+              <a:rPr lang="en-US" sz="6900" dirty="0" spc="-1" kern="0">
                 <a:solidFill>
                   <a:srgbClr val="14161C"/>
                 </a:solidFill>
@@ -3822,10 +3822,10 @@
                 <a:ea typeface="Bricolage Grotesque ExtraBold" pitchFamily="34" charset="-122"/>
                 <a:cs typeface="Bricolage Grotesque ExtraBold" pitchFamily="34" charset="-120"/>
               </a:rPr>
-              <a:t> thích</a:t>
-            </a:r>
-            <a:r>
-              <a:rPr lang="en-US" sz="6300" dirty="0" spc="3" kern="0">
+              <a:t> năm, mô</a:t>
+            </a:r>
+            <a:r>
+              <a:rPr lang="en-US" sz="6900" dirty="0" spc="3" kern="0">
                 <a:solidFill>
                   <a:srgbClr val="14161C"/>
                 </a:solidFill>
@@ -3833,10 +3833,10 @@
                 <a:ea typeface="Bricolage Grotesque ExtraBold" pitchFamily="34" charset="-122"/>
                 <a:cs typeface="Bricolage Grotesque ExtraBold" pitchFamily="34" charset="-120"/>
               </a:rPr>
-              <a:t> năm, mô phỏng</a:t>
-            </a:r>
-            <a:r>
-              <a:rPr lang="en-US" sz="6300" dirty="0" spc="-2" kern="0">
+              <a:t> phỏng</a:t>
+            </a:r>
+            <a:r>
+              <a:rPr lang="en-US" sz="6900" dirty="0" spc="2" kern="0">
                 <a:solidFill>
                   <a:srgbClr val="14161C"/>
                 </a:solidFill>
@@ -3846,7 +3846,7 @@
               </a:rPr>
               <a:t> sáu</a:t>
             </a:r>
-            <a:endParaRPr lang="en-US" sz="6300" dirty="0"/>
+            <a:endParaRPr lang="en-US" sz="6900" dirty="0"/>
           </a:p>
         </p:txBody>
       </p:sp>
@@ -5452,7 +5452,7 @@
               <a:buNone/>
             </a:pPr>
             <a:r>
-              <a:rPr lang="en-US" sz="6300" dirty="0" spc="0" kern="0">
+              <a:rPr lang="en-US" sz="6900" dirty="0" spc="-2" kern="0">
                 <a:solidFill>
                   <a:srgbClr val="14161C"/>
                 </a:solidFill>
@@ -5463,7 +5463,7 @@
               <a:t>LFU</a:t>
             </a:r>
             <a:r>
-              <a:rPr lang="en-US" sz="6300" dirty="0" spc="1" kern="0">
+              <a:rPr lang="en-US" sz="6900" dirty="0" spc="0" kern="0">
                 <a:solidFill>
                   <a:srgbClr val="14161C"/>
                 </a:solidFill>
@@ -5474,7 +5474,7 @@
               <a:t> giữ</a:t>
             </a:r>
             <a:r>
-              <a:rPr lang="en-US" sz="6300" dirty="0" spc="-7" kern="0">
+              <a:rPr lang="en-US" sz="6900" dirty="0" spc="-8" kern="0">
                 <a:solidFill>
                   <a:srgbClr val="14161C"/>
                 </a:solidFill>
@@ -5485,7 +5485,7 @@
               <a:t> khóa</a:t>
             </a:r>
             <a:r>
-              <a:rPr lang="en-US" sz="6300" dirty="0" spc="1" kern="0">
+              <a:rPr lang="en-US" sz="6900" dirty="0" spc="0" kern="0">
                 <a:solidFill>
                   <a:srgbClr val="14161C"/>
                 </a:solidFill>
@@ -5496,7 +5496,7 @@
               <a:t> hay</a:t>
             </a:r>
             <a:r>
-              <a:rPr lang="en-US" sz="6300" dirty="0" spc="-78" kern="0">
+              <a:rPr lang="en-US" sz="6900" dirty="0" spc="-91" kern="0">
                 <a:solidFill>
                   <a:srgbClr val="14161C"/>
                 </a:solidFill>
@@ -5507,7 +5507,7 @@
               <a:t> được</a:t>
             </a:r>
             <a:r>
-              <a:rPr lang="en-US" sz="6300" dirty="0" spc="1" kern="0">
+              <a:rPr lang="en-US" sz="6900" dirty="0" spc="1" kern="0">
                 <a:solidFill>
                   <a:srgbClr val="14161C"/>
                 </a:solidFill>
@@ -5517,7 +5517,7 @@
               </a:rPr>
               <a:t> dùng</a:t>
             </a:r>
-            <a:endParaRPr lang="en-US" sz="6300" dirty="0"/>
+            <a:endParaRPr lang="en-US" sz="6900" dirty="0"/>
           </a:p>
         </p:txBody>
       </p:sp>
@@ -6366,7 +6366,7 @@
               <a:buNone/>
             </a:pPr>
             <a:r>
-              <a:rPr lang="en-US" sz="6300" dirty="0" spc="-24" kern="0">
+              <a:rPr lang="en-US" sz="6900" dirty="0" spc="-26" kern="0">
                 <a:solidFill>
                   <a:srgbClr val="F3EEE3"/>
                 </a:solidFill>
@@ -6377,7 +6377,7 @@
               <a:t>MRU</a:t>
             </a:r>
             <a:r>
-              <a:rPr lang="en-US" sz="6300" dirty="0" spc="-90" kern="0">
+              <a:rPr lang="en-US" sz="6900" dirty="0" spc="-103" kern="0">
                 <a:solidFill>
                   <a:srgbClr val="F3EEE3"/>
                 </a:solidFill>
@@ -6388,7 +6388,7 @@
               <a:t> cược</a:t>
             </a:r>
             <a:r>
-              <a:rPr lang="en-US" sz="6300" dirty="0" spc="-74" kern="0">
+              <a:rPr lang="en-US" sz="6900" dirty="0" spc="-84" kern="0">
                 <a:solidFill>
                   <a:srgbClr val="F3EEE3"/>
                 </a:solidFill>
@@ -6399,7 +6399,7 @@
               <a:t> ngược</a:t>
             </a:r>
             <a:r>
-              <a:rPr lang="en-US" sz="6300" dirty="0" spc="0" kern="0">
+              <a:rPr lang="en-US" sz="6900" dirty="0" spc="1" kern="0">
                 <a:solidFill>
                   <a:srgbClr val="F3EEE3"/>
                 </a:solidFill>
@@ -6409,7 +6409,7 @@
               </a:rPr>
               <a:t> lại</a:t>
             </a:r>
-            <a:endParaRPr lang="en-US" sz="6300" dirty="0"/>
+            <a:endParaRPr lang="en-US" sz="6900" dirty="0"/>
           </a:p>
         </p:txBody>
       </p:sp>
@@ -7333,7 +7333,7 @@
               <a:buNone/>
             </a:pPr>
             <a:r>
-              <a:rPr lang="en-US" sz="6300" dirty="0" spc="-20" kern="0">
+              <a:rPr lang="en-US" sz="6900" dirty="0" spc="-19" kern="0">
                 <a:solidFill>
                   <a:srgbClr val="F3EEE3"/>
                 </a:solidFill>
@@ -7344,7 +7344,7 @@
               <a:t>SLRU</a:t>
             </a:r>
             <a:r>
-              <a:rPr lang="en-US" sz="6300" dirty="0" spc="0" kern="0">
+              <a:rPr lang="en-US" sz="6900" dirty="0" spc="-1" kern="0">
                 <a:solidFill>
                   <a:srgbClr val="F3EEE3"/>
                 </a:solidFill>
@@ -7355,7 +7355,7 @@
               <a:t> chia</a:t>
             </a:r>
             <a:r>
-              <a:rPr lang="en-US" sz="6300" dirty="0" spc="1" kern="0">
+              <a:rPr lang="en-US" sz="6900" dirty="0" spc="0" kern="0">
                 <a:solidFill>
                   <a:srgbClr val="F3EEE3"/>
                 </a:solidFill>
@@ -7366,7 +7366,7 @@
               <a:t> bộ</a:t>
             </a:r>
             <a:r>
-              <a:rPr lang="en-US" sz="6300" dirty="0" spc="18" kern="0">
+              <a:rPr lang="en-US" sz="6900" dirty="0" spc="16" kern="0">
                 <a:solidFill>
                   <a:srgbClr val="F3EEE3"/>
                 </a:solidFill>
@@ -7377,7 +7377,7 @@
               <a:t> đệm</a:t>
             </a:r>
             <a:r>
-              <a:rPr lang="en-US" sz="6300" dirty="0" spc="3" kern="0">
+              <a:rPr lang="en-US" sz="6900" dirty="0" spc="3" kern="0">
                 <a:solidFill>
                   <a:srgbClr val="F3EEE3"/>
                 </a:solidFill>
@@ -7388,7 +7388,7 @@
               <a:t> thành</a:t>
             </a:r>
             <a:r>
-              <a:rPr lang="en-US" sz="6300" dirty="0" spc="1" kern="0">
+              <a:rPr lang="en-US" sz="6900" dirty="0" spc="0" kern="0">
                 <a:solidFill>
                   <a:srgbClr val="F3EEE3"/>
                 </a:solidFill>
@@ -7398,7 +7398,7 @@
               </a:rPr>
               <a:t> vùng</a:t>
             </a:r>
-            <a:endParaRPr lang="en-US" sz="6300" dirty="0"/>
+            <a:endParaRPr lang="en-US" sz="6900" dirty="0"/>
           </a:p>
         </p:txBody>
       </p:sp>
@@ -8360,7 +8360,7 @@
               <a:buNone/>
             </a:pPr>
             <a:r>
-              <a:rPr lang="en-US" sz="6300" dirty="0" spc="-29" kern="0">
+              <a:rPr lang="en-US" sz="6900" dirty="0" spc="-31" kern="0">
                 <a:solidFill>
                   <a:srgbClr val="14161C"/>
                 </a:solidFill>
@@ -8371,7 +8371,7 @@
               <a:t>Giới</a:t>
             </a:r>
             <a:r>
-              <a:rPr lang="en-US" sz="6300" dirty="0" spc="3" kern="0">
+              <a:rPr lang="en-US" sz="6900" dirty="0" spc="2" kern="0">
                 <a:solidFill>
                   <a:srgbClr val="14161C"/>
                 </a:solidFill>
@@ -8382,7 +8382,7 @@
               <a:t> hạn</a:t>
             </a:r>
             <a:r>
-              <a:rPr lang="en-US" sz="6300" dirty="0" spc="0" kern="0">
+              <a:rPr lang="en-US" sz="6900" dirty="0" spc="-1" kern="0">
                 <a:solidFill>
                   <a:srgbClr val="14161C"/>
                 </a:solidFill>
@@ -8393,7 +8393,7 @@
               <a:t> cần</a:t>
             </a:r>
             <a:r>
-              <a:rPr lang="en-US" sz="6300" dirty="0" spc="4" kern="0">
+              <a:rPr lang="en-US" sz="6900" dirty="0" spc="1" kern="0">
                 <a:solidFill>
                   <a:srgbClr val="14161C"/>
                 </a:solidFill>
@@ -8403,7 +8403,7 @@
               </a:rPr>
               <a:t> nhớ</a:t>
             </a:r>
-            <a:endParaRPr lang="en-US" sz="6300" dirty="0"/>
+            <a:endParaRPr lang="en-US" sz="6900" dirty="0"/>
           </a:p>
         </p:txBody>
       </p:sp>
@@ -9786,7 +9786,7 @@
               <a:buNone/>
             </a:pPr>
             <a:r>
-              <a:rPr lang="en-US" sz="6300" dirty="0" spc="-150" kern="0">
+              <a:rPr lang="en-US" sz="6900" dirty="0" spc="-165" kern="0">
                 <a:solidFill>
                   <a:srgbClr val="14161C"/>
                 </a:solidFill>
@@ -9797,7 +9797,7 @@
               <a:t>Tác</a:t>
             </a:r>
             <a:r>
-              <a:rPr lang="en-US" sz="6300" dirty="0" spc="1" kern="0">
+              <a:rPr lang="en-US" sz="6900" dirty="0" spc="1" kern="0">
                 <a:solidFill>
                   <a:srgbClr val="14161C"/>
                 </a:solidFill>
@@ -9808,7 +9808,7 @@
               <a:t> vụ</a:t>
             </a:r>
             <a:r>
-              <a:rPr lang="en-US" sz="6300" dirty="0" spc="18" kern="0">
+              <a:rPr lang="en-US" sz="6900" dirty="0" spc="16" kern="0">
                 <a:solidFill>
                   <a:srgbClr val="14161C"/>
                 </a:solidFill>
@@ -9819,7 +9819,7 @@
               <a:t> đêm</a:t>
             </a:r>
             <a:r>
-              <a:rPr lang="en-US" sz="6300" dirty="0" spc="1" kern="0">
+              <a:rPr lang="en-US" sz="6900" dirty="0" spc="-1" kern="0">
                 <a:solidFill>
                   <a:srgbClr val="14161C"/>
                 </a:solidFill>
@@ -9830,7 +9830,7 @@
               <a:t> làm</a:t>
             </a:r>
             <a:r>
-              <a:rPr lang="en-US" sz="6300" dirty="0" spc="-18" kern="0">
+              <a:rPr lang="en-US" sz="6900" dirty="0" spc="-19" kern="0">
                 <a:solidFill>
                   <a:srgbClr val="14161C"/>
                 </a:solidFill>
@@ -9841,7 +9841,7 @@
               <a:t> trang</a:t>
             </a:r>
             <a:r>
-              <a:rPr lang="en-US" sz="6300" dirty="0" spc="1" kern="0">
+              <a:rPr lang="en-US" sz="6900" dirty="0" spc="-2" kern="0">
                 <a:solidFill>
                   <a:srgbClr val="14161C"/>
                 </a:solidFill>
@@ -9851,7 +9851,7 @@
               </a:rPr>
               <a:t> chậm</a:t>
             </a:r>
-            <a:endParaRPr lang="en-US" sz="6300" dirty="0"/>
+            <a:endParaRPr lang="en-US" sz="6900" dirty="0"/>
           </a:p>
         </p:txBody>
       </p:sp>
@@ -11177,7 +11177,7 @@
               <a:buNone/>
             </a:pPr>
             <a:r>
-              <a:rPr lang="en-US" sz="6300" dirty="0" spc="-46" kern="0">
+              <a:rPr lang="en-US" sz="6900" dirty="0" spc="-52" kern="0">
                 <a:solidFill>
                   <a:srgbClr val="F3EEE3"/>
                 </a:solidFill>
@@ -11188,7 +11188,7 @@
               <a:t>Tỷ</a:t>
             </a:r>
             <a:r>
-              <a:rPr lang="en-US" sz="6300" dirty="0" spc="0" kern="0">
+              <a:rPr lang="en-US" sz="6900" dirty="0" spc="3" kern="0">
                 <a:solidFill>
                   <a:srgbClr val="F3EEE3"/>
                 </a:solidFill>
@@ -11199,7 +11199,7 @@
               <a:t> lệ</a:t>
             </a:r>
             <a:r>
-              <a:rPr lang="en-US" sz="6300" dirty="0" spc="5" kern="0">
+              <a:rPr lang="en-US" sz="6900" dirty="0" spc="7" kern="0">
                 <a:solidFill>
                   <a:srgbClr val="F3EEE3"/>
                 </a:solidFill>
@@ -11210,7 +11210,7 @@
               <a:t> trúng</a:t>
             </a:r>
             <a:r>
-              <a:rPr lang="en-US" sz="6300" dirty="0" spc="-93" kern="0">
+              <a:rPr lang="en-US" sz="6900" dirty="0" spc="-97" kern="0">
                 <a:solidFill>
                   <a:srgbClr val="F3EEE3"/>
                 </a:solidFill>
@@ -11221,7 +11221,7 @@
               <a:t> (%)</a:t>
             </a:r>
             <a:r>
-              <a:rPr lang="en-US" sz="6300" dirty="0" spc="2" kern="0">
+              <a:rPr lang="en-US" sz="6900" dirty="0" spc="2" kern="0">
                 <a:solidFill>
                   <a:srgbClr val="F3EEE3"/>
                 </a:solidFill>
@@ -11229,10 +11229,10 @@
                 <a:ea typeface="Bricolage Grotesque ExtraBold" pitchFamily="34" charset="-122"/>
                 <a:cs typeface="Bricolage Grotesque ExtraBold" pitchFamily="34" charset="-120"/>
               </a:rPr>
-              <a:t> theo kiểu</a:t>
-            </a:r>
-            <a:r>
-              <a:rPr lang="en-US" sz="6300" dirty="0" spc="5" kern="0">
+              <a:t> theo</a:t>
+            </a:r>
+            <a:r>
+              <a:rPr lang="en-US" sz="6900" dirty="0" spc="6" kern="0">
                 <a:solidFill>
                   <a:srgbClr val="F3EEE3"/>
                 </a:solidFill>
@@ -11240,10 +11240,10 @@
                 <a:ea typeface="Bricolage Grotesque ExtraBold" pitchFamily="34" charset="-122"/>
                 <a:cs typeface="Bricolage Grotesque ExtraBold" pitchFamily="34" charset="-120"/>
               </a:rPr>
-              <a:t> truy</a:t>
-            </a:r>
-            <a:r>
-              <a:rPr lang="en-US" sz="6300" dirty="0" spc="0" kern="0">
+              <a:t> kiểu</a:t>
+            </a:r>
+            <a:r>
+              <a:rPr lang="en-US" sz="6900" dirty="0" spc="7" kern="0">
                 <a:solidFill>
                   <a:srgbClr val="F3EEE3"/>
                 </a:solidFill>
@@ -11251,9 +11251,20 @@
                 <a:ea typeface="Bricolage Grotesque ExtraBold" pitchFamily="34" charset="-122"/>
                 <a:cs typeface="Bricolage Grotesque ExtraBold" pitchFamily="34" charset="-120"/>
               </a:rPr>
+              <a:t> truy</a:t>
+            </a:r>
+            <a:r>
+              <a:rPr lang="en-US" sz="6900" dirty="0" spc="-3" kern="0">
+                <a:solidFill>
+                  <a:srgbClr val="F3EEE3"/>
+                </a:solidFill>
+                <a:latin typeface="Bricolage Grotesque ExtraBold" pitchFamily="34" charset="0"/>
+                <a:ea typeface="Bricolage Grotesque ExtraBold" pitchFamily="34" charset="-122"/>
+                <a:cs typeface="Bricolage Grotesque ExtraBold" pitchFamily="34" charset="-120"/>
+              </a:rPr>
               <a:t> cập</a:t>
             </a:r>
-            <a:endParaRPr lang="en-US" sz="6300" dirty="0"/>
+            <a:endParaRPr lang="en-US" sz="6900" dirty="0"/>
           </a:p>
         </p:txBody>
       </p:sp>

</xml_diff>

<commit_message>
Slides: keep every single-line bullet within ten words (eight decks)
Co-Authored-By: Claude Sonnet 5.5 <noreply@anthropic.com>
Claude-Session: https://claude.ai/code/session_01EhxTYrCJpuk4mcqCLwPdds
</commit_message>
<xml_diff>
--- a/system-design-101/vi/lessons/sd-06-010/slides/sd-06-010.pptx
+++ b/system-design-101/vi/lessons/sd-06-010/slides/sd-06-010.pptx
@@ -7840,17 +7840,6 @@
                 <a:ea typeface="Be Vietnam Pro" pitchFamily="34" charset="-122"/>
                 <a:cs typeface="Be Vietnam Pro" pitchFamily="34" charset="-120"/>
               </a:rPr>
-              <a:t> việc</a:t>
-            </a:r>
-            <a:r>
-              <a:rPr lang="en-US" sz="2400" dirty="0" spc="-4" kern="0">
-                <a:solidFill>
-                  <a:srgbClr val="9AA0B5"/>
-                </a:solidFill>
-                <a:latin typeface="Be Vietnam Pro" pitchFamily="34" charset="0"/>
-                <a:ea typeface="Be Vietnam Pro" pitchFamily="34" charset="-122"/>
-                <a:cs typeface="Be Vietnam Pro" pitchFamily="34" charset="-120"/>
-              </a:rPr>
               <a:t> quét</a:t>
             </a:r>
             <a:r>
@@ -8535,29 +8524,7 @@
               <a:t> phỏng</a:t>
             </a:r>
             <a:r>
-              <a:rPr lang="en-US" sz="2850" b="1" dirty="0" spc="1" kern="0">
-                <a:solidFill>
-                  <a:srgbClr val="14161C"/>
-                </a:solidFill>
-                <a:latin typeface="Be Vietnam Pro" pitchFamily="34" charset="0"/>
-                <a:ea typeface="Be Vietnam Pro" pitchFamily="34" charset="-122"/>
-                <a:cs typeface="Be Vietnam Pro" pitchFamily="34" charset="-120"/>
-              </a:rPr>
-              <a:t> chính</a:t>
-            </a:r>
-            <a:r>
-              <a:rPr lang="en-US" sz="2850" b="1" dirty="0" spc="-19" kern="0">
-                <a:solidFill>
-                  <a:srgbClr val="14161C"/>
-                </a:solidFill>
-                <a:latin typeface="Be Vietnam Pro" pitchFamily="34" charset="0"/>
-                <a:ea typeface="Be Vietnam Pro" pitchFamily="34" charset="-122"/>
-                <a:cs typeface="Be Vietnam Pro" pitchFamily="34" charset="-120"/>
-              </a:rPr>
-              <a:t> xác</a:t>
-            </a:r>
-            <a:r>
-              <a:rPr lang="en-US" sz="2850" b="1" dirty="0" spc="28" kern="0">
+              <a:rPr lang="en-US" sz="2850" b="1" dirty="0" spc="29" kern="0">
                 <a:solidFill>
                   <a:srgbClr val="14161C"/>
                 </a:solidFill>
@@ -8568,6 +8535,17 @@
               <a:t> từng</a:t>
             </a:r>
             <a:r>
+              <a:rPr lang="en-US" sz="2850" b="1" dirty="0" spc="-4" kern="0">
+                <a:solidFill>
+                  <a:srgbClr val="14161C"/>
+                </a:solidFill>
+                <a:latin typeface="Be Vietnam Pro" pitchFamily="34" charset="0"/>
+                <a:ea typeface="Be Vietnam Pro" pitchFamily="34" charset="-122"/>
+                <a:cs typeface="Be Vietnam Pro" pitchFamily="34" charset="-120"/>
+              </a:rPr>
+              <a:t> thuật</a:t>
+            </a:r>
+            <a:r>
               <a:rPr lang="en-US" sz="2850" b="1" dirty="0" spc="-3" kern="0">
                 <a:solidFill>
                   <a:srgbClr val="14161C"/>
@@ -8576,43 +8554,32 @@
                 <a:ea typeface="Be Vietnam Pro" pitchFamily="34" charset="-122"/>
                 <a:cs typeface="Be Vietnam Pro" pitchFamily="34" charset="-120"/>
               </a:rPr>
-              <a:t> thuật</a:t>
-            </a:r>
-            <a:r>
-              <a:rPr lang="en-US" sz="2850" b="1" dirty="0" spc="-4" kern="0">
-                <a:solidFill>
-                  <a:srgbClr val="14161C"/>
-                </a:solidFill>
-                <a:latin typeface="Be Vietnam Pro" pitchFamily="34" charset="0"/>
-                <a:ea typeface="Be Vietnam Pro" pitchFamily="34" charset="-122"/>
-                <a:cs typeface="Be Vietnam Pro" pitchFamily="34" charset="-120"/>
-              </a:rPr>
               <a:t> toán,</a:t>
             </a:r>
             <a:r>
+              <a:rPr lang="en-US" sz="2850" b="1" dirty="0" spc="3" kern="0">
+                <a:solidFill>
+                  <a:srgbClr val="14161C"/>
+                </a:solidFill>
+                <a:latin typeface="Be Vietnam Pro" pitchFamily="34" charset="0"/>
+                <a:ea typeface="Be Vietnam Pro" pitchFamily="34" charset="-122"/>
+                <a:cs typeface="Be Vietnam Pro" pitchFamily="34" charset="-120"/>
+              </a:rPr>
+              <a:t> dữ</a:t>
+            </a:r>
+            <a:r>
+              <a:rPr lang="en-US" sz="2850" b="1" dirty="0" spc="2" kern="0">
+                <a:solidFill>
+                  <a:srgbClr val="14161C"/>
+                </a:solidFill>
+                <a:latin typeface="Be Vietnam Pro" pitchFamily="34" charset="0"/>
+                <a:ea typeface="Be Vietnam Pro" pitchFamily="34" charset="-122"/>
+                <a:cs typeface="Be Vietnam Pro" pitchFamily="34" charset="-120"/>
+              </a:rPr>
+              <a:t> liệu</a:t>
+            </a:r>
+            <a:r>
               <a:rPr lang="en-US" sz="2850" b="1" dirty="0" spc="4" kern="0">
-                <a:solidFill>
-                  <a:srgbClr val="14161C"/>
-                </a:solidFill>
-                <a:latin typeface="Be Vietnam Pro" pitchFamily="34" charset="0"/>
-                <a:ea typeface="Be Vietnam Pro" pitchFamily="34" charset="-122"/>
-                <a:cs typeface="Be Vietnam Pro" pitchFamily="34" charset="-120"/>
-              </a:rPr>
-              <a:t> dữ</a:t>
-            </a:r>
-            <a:r>
-              <a:rPr lang="en-US" sz="2850" b="1" dirty="0" spc="1" kern="0">
-                <a:solidFill>
-                  <a:srgbClr val="14161C"/>
-                </a:solidFill>
-                <a:latin typeface="Be Vietnam Pro" pitchFamily="34" charset="0"/>
-                <a:ea typeface="Be Vietnam Pro" pitchFamily="34" charset="-122"/>
-                <a:cs typeface="Be Vietnam Pro" pitchFamily="34" charset="-120"/>
-              </a:rPr>
-              <a:t> liệu</a:t>
-            </a:r>
-            <a:r>
-              <a:rPr lang="en-US" sz="2850" b="1" dirty="0" spc="5" kern="0">
                 <a:solidFill>
                   <a:srgbClr val="14161C"/>
                 </a:solidFill>
@@ -9236,18 +9203,7 @@
               <a:t> thật,</a:t>
             </a:r>
             <a:r>
-              <a:rPr lang="en-US" sz="2850" b="1" dirty="0" spc="-13" kern="0">
-                <a:solidFill>
-                  <a:srgbClr val="14161C"/>
-                </a:solidFill>
-                <a:latin typeface="Be Vietnam Pro" pitchFamily="34" charset="0"/>
-                <a:ea typeface="Be Vietnam Pro" pitchFamily="34" charset="-122"/>
-                <a:cs typeface="Be Vietnam Pro" pitchFamily="34" charset="-120"/>
-              </a:rPr>
-              <a:t> rồi</a:t>
-            </a:r>
-            <a:r>
-              <a:rPr lang="en-US" sz="2850" b="1" dirty="0" spc="9" kern="0">
+              <a:rPr lang="en-US" sz="2850" b="1" dirty="0" spc="10" kern="0">
                 <a:solidFill>
                   <a:srgbClr val="14161C"/>
                 </a:solidFill>
@@ -9269,7 +9225,7 @@
               <a:t> tỷ</a:t>
             </a:r>
             <a:r>
-              <a:rPr lang="en-US" sz="2850" b="1" dirty="0" spc="-5" kern="0">
+              <a:rPr lang="en-US" sz="2850" b="1" dirty="0" spc="-6" kern="0">
                 <a:solidFill>
                   <a:srgbClr val="14161C"/>
                 </a:solidFill>
@@ -9280,7 +9236,7 @@
               <a:t> lệ</a:t>
             </a:r>
             <a:r>
-              <a:rPr lang="en-US" sz="2850" b="1" dirty="0" spc="-1" kern="0">
+              <a:rPr lang="en-US" sz="2850" b="1" dirty="0" spc="0" kern="0">
                 <a:solidFill>
                   <a:srgbClr val="14161C"/>
                 </a:solidFill>
@@ -10074,17 +10030,6 @@
                 <a:cs typeface="Be Vietnam Pro" pitchFamily="34" charset="-120"/>
               </a:rPr>
               <a:t> đệm</a:t>
-            </a:r>
-            <a:r>
-              <a:rPr lang="en-US" sz="2550" dirty="0" spc="-1" kern="0">
-                <a:solidFill>
-                  <a:srgbClr val="14161C"/>
-                </a:solidFill>
-                <a:latin typeface="Be Vietnam Pro" pitchFamily="34" charset="0"/>
-                <a:ea typeface="Be Vietnam Pro" pitchFamily="34" charset="-122"/>
-                <a:cs typeface="Be Vietnam Pro" pitchFamily="34" charset="-120"/>
-              </a:rPr>
-              <a:t> dùng</a:t>
             </a:r>
             <a:r>
               <a:rPr lang="en-US" sz="2550" dirty="0" spc="-14" kern="0">

</xml_diff>